<commit_message>
feat: Enhance PowerPoint templates with professional design and rich content
Enhanced all 5 pitch deck templates with:
- Professional color palette (dark blue, light blue, green, orange)
- Richer, more informative content on each slide
- Concrete examples and supporting points embedded in slides
- Visual elements: colored top bars, TAM/SAM/SOM boxes, competition matrices
- Multi-level bullet formatting with indentation and color coding
- Improved typography using Calibri font throughout
- Better spacing and layout with decorative footer elements
- Consistent theme applied across all templates

Templates enhanced:
- Problem-Solution Framework (182KB)
- Traction-Heavy Framework (163KB)
- Vision-Driven Framework (159KB)
- Product Demo Framework (181KB)
- SaaS B2B Framework (175KB)

Co-Authored-By: Claude Sonnet 4.5 <noreply@anthropic.com>
</commit_message>
<xml_diff>
--- a/public/templates/product-demo.pptx
+++ b/public/templates/product-demo.pptx
@@ -18,10 +18,9 @@
     <p:sldId id="266" r:id="rId12"/>
     <p:sldId id="267" r:id="rId13"/>
     <p:sldId id="268" r:id="rId14"/>
-    <p:sldId id="269" r:id="rId15"/>
   </p:sldIdLst>
   <p:notesMasterIdLst>
-    <p:notesMasterId r:id="rId16"/>
+    <p:notesMasterId r:id="rId15"/>
   </p:notesMasterIdLst>
   <p:sldSz cx="9144000" cy="5143500"/>
   <p:notesSz cx="5143500" cy="9144000"/>
@@ -603,11 +602,7 @@
           <a:p>
             <a:r>
               <a:rPr lang="en-US" dirty="0"/>
-              <a:t>Instructions for "Market &amp; Customers" slide:
-Target customer profile
-Market size
-Early customers/users
-Replace this content with your own information.</a:t>
+              <a:t/>
             </a:r>
             <a:endParaRPr lang="en-US" dirty="0"/>
           </a:p>
@@ -695,12 +690,7 @@
           <a:p>
             <a:r>
               <a:rPr lang="en-US" dirty="0"/>
-              <a:t>Instructions for "Traction" slide:
-User metrics
-Usage statistics
-Retention data
-Customer feedback
-Replace this content with your own information.</a:t>
+              <a:t/>
             </a:r>
             <a:endParaRPr lang="en-US" dirty="0"/>
           </a:p>
@@ -788,12 +778,7 @@
           <a:p>
             <a:r>
               <a:rPr lang="en-US" dirty="0"/>
-              <a:t>Instructions for "Roadmap" slide:
-Upcoming features
-Product expansion
-Platform vision
-Timeline
-Replace this content with your own information.</a:t>
+              <a:t/>
             </a:r>
             <a:endParaRPr lang="en-US" dirty="0"/>
           </a:p>
@@ -881,11 +866,7 @@
           <a:p>
             <a:r>
               <a:rPr lang="en-US" dirty="0"/>
-              <a:t>Instructions for "Team" slide:
-Technical founders
-Product expertise
-Previous products built
-Replace this content with your own information.</a:t>
+              <a:t/>
             </a:r>
             <a:endParaRPr lang="en-US" dirty="0"/>
           </a:p>
@@ -909,99 +890,6 @@
             <a:fld id="{F7021451-1387-4CA6-816F-3879F97B5CBC}" type="slidenum">
               <a:rPr lang="en-US"/>
               <a:t>13</a:t>
-            </a:fld>
-            <a:endParaRPr lang="en-US"/>
-          </a:p>
-        </p:txBody>
-      </p:sp>
-    </p:spTree>
-    <p:extLst>
-      <p:ext uri="{BB962C8B-B14F-4D97-AF65-F5344CB8AC3E}">
-        <p14:creationId xmlns:p14="http://schemas.microsoft.com/office/powerpoint/2010/main" val="1024086991"/>
-      </p:ext>
-    </p:extLst>
-  </p:cSld>
-  <p:clrMapOvr>
-    <a:masterClrMapping/>
-  </p:clrMapOvr>
-</p:notes>
-</file>
-
-<file path=ppt/notesSlides/notesSlide14.xml><?xml version="1.0" encoding="utf-8"?>
-<p:notes xmlns:a="http://schemas.openxmlformats.org/drawingml/2006/main" xmlns:r="http://schemas.openxmlformats.org/officeDocument/2006/relationships" xmlns:p="http://schemas.openxmlformats.org/presentationml/2006/main">
-  <p:cSld>
-    <p:spTree>
-      <p:nvGrpSpPr>
-        <p:cNvPr id="1" name=""/>
-        <p:cNvGrpSpPr/>
-        <p:nvPr/>
-      </p:nvGrpSpPr>
-      <p:grpSpPr>
-        <a:xfrm>
-          <a:off x="0" y="0"/>
-          <a:ext cx="0" cy="0"/>
-          <a:chOff x="0" y="0"/>
-          <a:chExt cx="0" cy="0"/>
-        </a:xfrm>
-      </p:grpSpPr>
-      <p:sp>
-        <p:nvSpPr>
-          <p:cNvPr id="2" name="Slide Image Placeholder 1"/>
-          <p:cNvSpPr>
-            <a:spLocks noGrp="1" noRot="1" noChangeAspect="1"/>
-          </p:cNvSpPr>
-          <p:nvPr>
-            <p:ph type="sldImg"/>
-          </p:nvPr>
-        </p:nvSpPr>
-        <p:spPr/>
-      </p:sp>
-      <p:sp>
-        <p:nvSpPr>
-          <p:cNvPr id="3" name="Notes Placeholder 2"/>
-          <p:cNvSpPr>
-            <a:spLocks noGrp="1"/>
-          </p:cNvSpPr>
-          <p:nvPr>
-            <p:ph type="body" idx="1"/>
-          </p:nvPr>
-        </p:nvSpPr>
-        <p:spPr/>
-        <p:txBody>
-          <a:bodyPr/>
-          <a:lstStyle/>
-          <a:p>
-            <a:r>
-              <a:rPr lang="en-US" dirty="0"/>
-              <a:t>Instructions for "Ask" slide:
-Funding amount
-Use for product development
-Hiring plan
-Go-to-market acceleration
-Replace this content with your own information.</a:t>
-            </a:r>
-            <a:endParaRPr lang="en-US" dirty="0"/>
-          </a:p>
-        </p:txBody>
-      </p:sp>
-      <p:sp>
-        <p:nvSpPr>
-          <p:cNvPr id="4" name="Slide Number Placeholder 3"/>
-          <p:cNvSpPr>
-            <a:spLocks noGrp="1"/>
-          </p:cNvSpPr>
-          <p:nvPr>
-            <p:ph type="sldNum" sz="quarter" idx="10"/>
-          </p:nvPr>
-        </p:nvSpPr>
-        <p:spPr/>
-        <p:txBody>
-          <a:bodyPr/>
-          <a:lstStyle/>
-          <a:p>
-            <a:fld id="{F7021451-1387-4CA6-816F-3879F97B5CBC}" type="slidenum">
-              <a:rPr lang="en-US"/>
-              <a:t>14</a:t>
             </a:fld>
             <a:endParaRPr lang="en-US"/>
           </a:p>
@@ -1066,11 +954,7 @@
           <a:p>
             <a:r>
               <a:rPr lang="en-US" dirty="0"/>
-              <a:t>Instructions for "Cover Slide" slide:
-Company and product name
-One-line value prop
-Product screenshot
-Replace this content with your own information.</a:t>
+              <a:t/>
             </a:r>
             <a:endParaRPr lang="en-US" dirty="0"/>
           </a:p>
@@ -1158,11 +1042,7 @@
           <a:p>
             <a:r>
               <a:rPr lang="en-US" dirty="0"/>
-              <a:t>Instructions for "Problem" slide:
-Specific user problem
-Current workflow pain
-Quantify the impact
-Replace this content with your own information.</a:t>
+              <a:t/>
             </a:r>
             <a:endParaRPr lang="en-US" dirty="0"/>
           </a:p>
@@ -1250,11 +1130,7 @@
           <a:p>
             <a:r>
               <a:rPr lang="en-US" dirty="0"/>
-              <a:t>Instructions for "Solution Overview" slide:
-How your product solves it
-Core value proposition
-Why it's better
-Replace this content with your own information.</a:t>
+              <a:t/>
             </a:r>
             <a:endParaRPr lang="en-US" dirty="0"/>
           </a:p>
@@ -1342,12 +1218,7 @@
           <a:p>
             <a:r>
               <a:rPr lang="en-US" dirty="0"/>
-              <a:t>Instructions for "Product Demo - Main Interface" slide:
-Main dashboard or interface
-Primary use case
-Clear annotations
-Focus on user benefit
-Replace this content with your own information.</a:t>
+              <a:t/>
             </a:r>
             <a:endParaRPr lang="en-US" dirty="0"/>
           </a:p>
@@ -1435,11 +1306,7 @@
           <a:p>
             <a:r>
               <a:rPr lang="en-US" dirty="0"/>
-              <a:t>Instructions for "Product Demo - Key Feature" slide:
-Key differentiating feature
-How it works
-User workflow
-Replace this content with your own information.</a:t>
+              <a:t/>
             </a:r>
             <a:endParaRPr lang="en-US" dirty="0"/>
           </a:p>
@@ -1527,11 +1394,7 @@
           <a:p>
             <a:r>
               <a:rPr lang="en-US" dirty="0"/>
-              <a:t>Instructions for "Product Demo - Advanced Features" slide:
-Power user features
-Integration capabilities
-Customization options
-Replace this content with your own information.</a:t>
+              <a:t/>
             </a:r>
             <a:endParaRPr lang="en-US" dirty="0"/>
           </a:p>
@@ -1619,12 +1482,7 @@
           <a:p>
             <a:r>
               <a:rPr lang="en-US" dirty="0"/>
-              <a:t>Instructions for "User Experience" slide:
-Onboarding flow
-Ease of use
-Time to value
-User testimonials
-Replace this content with your own information.</a:t>
+              <a:t/>
             </a:r>
             <a:endParaRPr lang="en-US" dirty="0"/>
           </a:p>
@@ -1712,12 +1570,7 @@
           <a:p>
             <a:r>
               <a:rPr lang="en-US" dirty="0"/>
-              <a:t>Instructions for "Technology" slide:
-Architecture overview
-Technical innovation
-Scalability
-Security/compliance
-Replace this content with your own information.</a:t>
+              <a:t/>
             </a:r>
             <a:endParaRPr lang="en-US" dirty="0"/>
           </a:p>
@@ -1789,74 +1642,6 @@
 </p:sldLayout>
 </file>
 
-<file path=ppt/slideLayouts/slideLayout2.xml><?xml version="1.0" encoding="utf-8"?>
-<p:sldLayout xmlns:a="http://schemas.openxmlformats.org/drawingml/2006/main" xmlns:r="http://schemas.openxmlformats.org/officeDocument/2006/relationships" xmlns:p="http://schemas.openxmlformats.org/presentationml/2006/main" preserve="1">
-  <p:cSld name="MASTER_SLIDE">
-    <p:bg>
-      <p:bgPr>
-        <a:solidFill>
-          <a:srgbClr val="FFFFFF"/>
-        </a:solidFill>
-      </p:bgPr>
-    </p:bg>
-    <p:spTree>
-      <p:nvGrpSpPr>
-        <p:cNvPr id="1" name=""/>
-        <p:cNvGrpSpPr/>
-        <p:nvPr/>
-      </p:nvGrpSpPr>
-      <p:grpSpPr>
-        <a:xfrm>
-          <a:off x="0" y="0"/>
-          <a:ext cx="0" cy="0"/>
-          <a:chOff x="0" y="0"/>
-          <a:chExt cx="0" cy="0"/>
-        </a:xfrm>
-      </p:grpSpPr>
-      <p:sp>
-        <p:nvSpPr>
-          <p:cNvPr id="2" name="Text 0"/>
-          <p:cNvSpPr/>
-          <p:nvPr/>
-        </p:nvSpPr>
-        <p:spPr>
-          <a:xfrm>
-            <a:off x="457200" y="6217920"/>
-            <a:ext cx="8229600" cy="274320"/>
-          </a:xfrm>
-          <a:prstGeom prst="rect">
-            <a:avLst/>
-          </a:prstGeom>
-          <a:noFill/>
-          <a:ln/>
-        </p:spPr>
-        <p:txBody>
-          <a:bodyPr wrap="square" rtlCol="0" anchor="ctr"/>
-          <a:lstStyle/>
-          <a:p>
-            <a:pPr algn="r" indent="0" marL="0">
-              <a:buNone/>
-            </a:pPr>
-            <a:r>
-              <a:rPr lang="en-US" sz="1000" dirty="0">
-                <a:solidFill>
-                  <a:srgbClr val="666666"/>
-                </a:solidFill>
-              </a:rPr>
-              <a:t>Creatives Takeover</a:t>
-            </a:r>
-            <a:endParaRPr lang="en-US" sz="1000" dirty="0"/>
-          </a:p>
-        </p:txBody>
-      </p:sp>
-    </p:spTree>
-  </p:cSld>
-  <p:clrMapOvr>
-    <a:masterClrMapping/>
-  </p:clrMapOvr>
-</p:sldLayout>
-</file>
-
 <file path=ppt/slideMasters/slideMaster1.xml><?xml version="1.0" encoding="utf-8"?>
 <p:sldMaster xmlns:a="http://schemas.openxmlformats.org/drawingml/2006/main" xmlns:r="http://schemas.openxmlformats.org/officeDocument/2006/relationships" xmlns:p="http://schemas.openxmlformats.org/presentationml/2006/main">
   <p:cSld>
@@ -1879,7 +1664,6 @@
   <p:clrMap bg1="lt1" tx1="dk1" bg2="lt2" tx2="dk2" accent1="accent1" accent2="accent2" accent3="accent3" accent4="accent4" accent5="accent5" accent6="accent6" hlink="hlink" folHlink="folHlink"/>
   <p:sldLayoutIdLst>
     <p:sldLayoutId id="2147483649" r:id="rId1"/>
-    <p:sldLayoutId id="2147483650" r:id="rId2"/>
   </p:sldLayoutIdLst>
   <p:hf sldNum="0" hdr="0" ftr="0" dt="0"/>
   <p:txStyles>
@@ -2168,7 +1952,7 @@
         <p:spPr>
           <a:xfrm>
             <a:off x="457200" y="2286000"/>
-            <a:ext cx="8229600" cy="1371600"/>
+            <a:ext cx="8229600" cy="1097280"/>
           </a:xfrm>
           <a:prstGeom prst="rect">
             <a:avLst/>
@@ -2184,14 +1968,17 @@
               <a:buNone/>
             </a:pPr>
             <a:r>
-              <a:rPr lang="en-US" sz="4400" b="1" dirty="0">
+              <a:rPr lang="en-US" sz="4800" b="1" dirty="0">
                 <a:solidFill>
                   <a:srgbClr val="FFFFFF"/>
                 </a:solidFill>
-              </a:rPr>
-              <a:t>Product Demo Deck</a:t>
-            </a:r>
-            <a:endParaRPr lang="en-US" sz="4400" dirty="0"/>
+                <a:latin typeface="Calibri" pitchFamily="34" charset="0"/>
+                <a:ea typeface="Calibri" pitchFamily="34" charset="-122"/>
+                <a:cs typeface="Calibri" pitchFamily="34" charset="-120"/>
+              </a:rPr>
+              <a:t>Product Demo</a:t>
+            </a:r>
+            <a:endParaRPr lang="en-US" sz="4800" dirty="0"/>
           </a:p>
         </p:txBody>
       </p:sp>
@@ -2203,8 +1990,8 @@
         </p:nvSpPr>
         <p:spPr>
           <a:xfrm>
-            <a:off x="457200" y="3657600"/>
-            <a:ext cx="8229600" cy="457200"/>
+            <a:off x="457200" y="3474720"/>
+            <a:ext cx="8229600" cy="548640"/>
           </a:xfrm>
           <a:prstGeom prst="rect">
             <a:avLst/>
@@ -2220,50 +2007,17 @@
               <a:buNone/>
             </a:pPr>
             <a:r>
-              <a:rPr lang="en-US" sz="2000" dirty="0">
+              <a:rPr lang="en-US" sz="2400" dirty="0">
                 <a:solidFill>
                   <a:srgbClr val="38BDF8"/>
                 </a:solidFill>
-              </a:rPr>
-              <a:t>Editable Template</a:t>
-            </a:r>
-            <a:endParaRPr lang="en-US" sz="2000" dirty="0"/>
-          </a:p>
-        </p:txBody>
-      </p:sp>
-      <p:sp>
-        <p:nvSpPr>
-          <p:cNvPr id="4" name="Text 2"/>
-          <p:cNvSpPr/>
-          <p:nvPr/>
-        </p:nvSpPr>
-        <p:spPr>
-          <a:xfrm>
-            <a:off x="457200" y="4297680"/>
-            <a:ext cx="8229600" cy="274320"/>
-          </a:xfrm>
-          <a:prstGeom prst="rect">
-            <a:avLst/>
-          </a:prstGeom>
-          <a:noFill/>
-          <a:ln/>
-        </p:spPr>
-        <p:txBody>
-          <a:bodyPr wrap="square" rtlCol="0" anchor="ctr"/>
-          <a:lstStyle/>
-          <a:p>
-            <a:pPr algn="ctr" indent="0" marL="0">
-              <a:buNone/>
-            </a:pPr>
-            <a:r>
-              <a:rPr lang="en-US" sz="1400" dirty="0">
-                <a:solidFill>
-                  <a:srgbClr val="CCCCCC"/>
-                </a:solidFill>
-              </a:rPr>
-              <a:t>Created by Creatives Takeover</a:t>
-            </a:r>
-            <a:endParaRPr lang="en-US" sz="1400" dirty="0"/>
+                <a:latin typeface="Calibri" pitchFamily="34" charset="0"/>
+                <a:ea typeface="Calibri" pitchFamily="34" charset="-122"/>
+                <a:cs typeface="Calibri" pitchFamily="34" charset="-120"/>
+              </a:rPr>
+              <a:t>Show, don't tell</a:t>
+            </a:r>
+            <a:endParaRPr lang="en-US" sz="2400" dirty="0"/>
           </a:p>
         </p:txBody>
       </p:sp>
@@ -2278,6 +2032,13 @@
 <file path=ppt/slides/slide10.xml><?xml version="1.0" encoding="utf-8"?>
 <p:sld xmlns:a="http://schemas.openxmlformats.org/drawingml/2006/main" xmlns:r="http://schemas.openxmlformats.org/officeDocument/2006/relationships" xmlns:p="http://schemas.openxmlformats.org/presentationml/2006/main">
   <p:cSld name="Slide 10">
+    <p:bg>
+      <p:bgPr>
+        <a:solidFill>
+          <a:srgbClr val="FFFFFF"/>
+        </a:solidFill>
+      </p:bgPr>
+    </p:bg>
     <p:spTree>
       <p:nvGrpSpPr>
         <p:cNvPr id="1" name=""/>
@@ -2294,14 +2055,34 @@
       </p:grpSpPr>
       <p:sp>
         <p:nvSpPr>
-          <p:cNvPr id="2" name="Text 0"/>
-          <p:cNvSpPr/>
-          <p:nvPr/>
-        </p:nvSpPr>
-        <p:spPr>
-          <a:xfrm>
-            <a:off x="457200" y="457200"/>
-            <a:ext cx="8229600" cy="685800"/>
+          <p:cNvPr id="2" name="Shape 0"/>
+          <p:cNvSpPr/>
+          <p:nvPr/>
+        </p:nvSpPr>
+        <p:spPr>
+          <a:xfrm>
+            <a:off x="0" y="0"/>
+            <a:ext cx="9144000" cy="137160"/>
+          </a:xfrm>
+          <a:prstGeom prst="rect">
+            <a:avLst/>
+          </a:prstGeom>
+          <a:solidFill>
+            <a:srgbClr val="0B1437"/>
+          </a:solidFill>
+          <a:ln/>
+        </p:spPr>
+      </p:sp>
+      <p:sp>
+        <p:nvSpPr>
+          <p:cNvPr id="3" name="Text 1"/>
+          <p:cNvSpPr/>
+          <p:nvPr/>
+        </p:nvSpPr>
+        <p:spPr>
+          <a:xfrm>
+            <a:off x="457200" y="365760"/>
+            <a:ext cx="8229600" cy="548640"/>
           </a:xfrm>
           <a:prstGeom prst="rect">
             <a:avLst/>
@@ -2321,8 +2102,11 @@
                 <a:solidFill>
                   <a:srgbClr val="0B1437"/>
                 </a:solidFill>
-              </a:rPr>
-              <a:t>Market &amp; Customers</a:t>
+                <a:latin typeface="Calibri" pitchFamily="34" charset="0"/>
+                <a:ea typeface="Calibri" pitchFamily="34" charset="-122"/>
+                <a:cs typeface="Calibri" pitchFamily="34" charset="-120"/>
+              </a:rPr>
+              <a:t>Mobile Experience</a:t>
             </a:r>
             <a:endParaRPr lang="en-US" sz="3200" dirty="0"/>
           </a:p>
@@ -2330,7 +2114,46 @@
       </p:sp>
       <p:sp>
         <p:nvSpPr>
-          <p:cNvPr id="3" name="Text 1"/>
+          <p:cNvPr id="4" name="Text 2"/>
+          <p:cNvSpPr/>
+          <p:nvPr/>
+        </p:nvSpPr>
+        <p:spPr>
+          <a:xfrm>
+            <a:off x="457200" y="914400"/>
+            <a:ext cx="8229600" cy="365760"/>
+          </a:xfrm>
+          <a:prstGeom prst="rect">
+            <a:avLst/>
+          </a:prstGeom>
+          <a:noFill/>
+          <a:ln/>
+        </p:spPr>
+        <p:txBody>
+          <a:bodyPr wrap="square" rtlCol="0" anchor="ctr"/>
+          <a:lstStyle/>
+          <a:p>
+            <a:pPr indent="0" marL="0">
+              <a:buNone/>
+            </a:pPr>
+            <a:r>
+              <a:rPr lang="en-US" sz="1600" i="1" dirty="0">
+                <a:solidFill>
+                  <a:srgbClr val="6B7280"/>
+                </a:solidFill>
+                <a:latin typeface="Calibri" pitchFamily="34" charset="0"/>
+                <a:ea typeface="Calibri" pitchFamily="34" charset="-122"/>
+                <a:cs typeface="Calibri" pitchFamily="34" charset="-120"/>
+              </a:rPr>
+              <a:t>Manage your business on the go</a:t>
+            </a:r>
+            <a:endParaRPr lang="en-US" sz="1600" dirty="0"/>
+          </a:p>
+        </p:txBody>
+      </p:sp>
+      <p:sp>
+        <p:nvSpPr>
+          <p:cNvPr id="5" name="Text 3"/>
           <p:cNvSpPr/>
           <p:nvPr/>
         </p:nvSpPr>
@@ -2357,14 +2180,17 @@
               <a:buChar char="•"/>
             </a:pPr>
             <a:r>
-              <a:rPr lang="en-US" sz="1600" dirty="0">
-                <a:solidFill>
-                  <a:srgbClr val="374151"/>
-                </a:solidFill>
-              </a:rPr>
-              <a:t>Target customer profile</a:t>
-            </a:r>
-            <a:endParaRPr lang="en-US" sz="1600" dirty="0"/>
+              <a:rPr lang="en-US" sz="1800" b="1" dirty="0">
+                <a:solidFill>
+                  <a:srgbClr val="1F2937"/>
+                </a:solidFill>
+                <a:latin typeface="Calibri" pitchFamily="34" charset="0"/>
+                <a:ea typeface="Calibri" pitchFamily="34" charset="-122"/>
+                <a:cs typeface="Calibri" pitchFamily="34" charset="-120"/>
+              </a:rPr>
+              <a:t>Screenshot: Mobile app</a:t>
+            </a:r>
+            <a:endParaRPr lang="en-US" sz="1800" dirty="0"/>
           </a:p>
           <a:p>
             <a:pPr marL="342900" indent="-342900">
@@ -2375,14 +2201,17 @@
               <a:buChar char="•"/>
             </a:pPr>
             <a:r>
-              <a:rPr lang="en-US" sz="1600" dirty="0">
-                <a:solidFill>
-                  <a:srgbClr val="374151"/>
-                </a:solidFill>
-              </a:rPr>
-              <a:t>Market size</a:t>
-            </a:r>
-            <a:endParaRPr lang="en-US" sz="1600" dirty="0"/>
+              <a:rPr lang="en-US" sz="1800" b="1" dirty="0">
+                <a:solidFill>
+                  <a:srgbClr val="1F2937"/>
+                </a:solidFill>
+                <a:latin typeface="Calibri" pitchFamily="34" charset="0"/>
+                <a:ea typeface="Calibri" pitchFamily="34" charset="-122"/>
+                <a:cs typeface="Calibri" pitchFamily="34" charset="-120"/>
+              </a:rPr>
+              <a:t>Create and send invoices from your phone</a:t>
+            </a:r>
+            <a:endParaRPr lang="en-US" sz="1800" dirty="0"/>
           </a:p>
           <a:p>
             <a:pPr marL="342900" indent="-342900">
@@ -2393,14 +2222,157 @@
               <a:buChar char="•"/>
             </a:pPr>
             <a:r>
-              <a:rPr lang="en-US" sz="1600" dirty="0">
-                <a:solidFill>
-                  <a:srgbClr val="374151"/>
-                </a:solidFill>
-              </a:rPr>
-              <a:t>Early customers/users</a:t>
-            </a:r>
-            <a:endParaRPr lang="en-US" sz="1600" dirty="0"/>
+              <a:rPr lang="en-US" sz="1800" b="1" dirty="0">
+                <a:solidFill>
+                  <a:srgbClr val="1F2937"/>
+                </a:solidFill>
+                <a:latin typeface="Calibri" pitchFamily="34" charset="0"/>
+                <a:ea typeface="Calibri" pitchFamily="34" charset="-122"/>
+                <a:cs typeface="Calibri" pitchFamily="34" charset="-120"/>
+              </a:rPr>
+              <a:t>Receive push notifications when invoices are viewed or paid</a:t>
+            </a:r>
+            <a:endParaRPr lang="en-US" sz="1800" dirty="0"/>
+          </a:p>
+          <a:p>
+            <a:pPr lvl="1" marL="685800" indent="-342900">
+              <a:lnSpc>
+                <a:spcPts val="2800"/>
+              </a:lnSpc>
+              <a:buSzPct val="100000"/>
+              <a:buChar char="•"/>
+            </a:pPr>
+            <a:r>
+              <a:rPr lang="en-US" sz="1800" dirty="0">
+                <a:solidFill>
+                  <a:srgbClr val="6B7280"/>
+                </a:solidFill>
+                <a:latin typeface="Calibri" pitchFamily="34" charset="0"/>
+                <a:ea typeface="Calibri" pitchFamily="34" charset="-122"/>
+                <a:cs typeface="Calibri" pitchFamily="34" charset="-120"/>
+              </a:rPr>
+              <a:t>Example: "Sarah viewed Invoice #1234 - good time to follow up!"</a:t>
+            </a:r>
+            <a:endParaRPr lang="en-US" sz="1800" dirty="0"/>
+          </a:p>
+          <a:p>
+            <a:pPr marL="342900" indent="-342900">
+              <a:lnSpc>
+                <a:spcPts val="2800"/>
+              </a:lnSpc>
+              <a:buSzPct val="100000"/>
+              <a:buChar char="•"/>
+            </a:pPr>
+            <a:r>
+              <a:rPr lang="en-US" sz="1800" b="1" dirty="0">
+                <a:solidFill>
+                  <a:srgbClr val="1F2937"/>
+                </a:solidFill>
+                <a:latin typeface="Calibri" pitchFamily="34" charset="0"/>
+                <a:ea typeface="Calibri" pitchFamily="34" charset="-122"/>
+                <a:cs typeface="Calibri" pitchFamily="34" charset="-120"/>
+              </a:rPr>
+              <a:t>Review cash flow and payment status anywhere</a:t>
+            </a:r>
+            <a:endParaRPr lang="en-US" sz="1800" dirty="0"/>
+          </a:p>
+        </p:txBody>
+      </p:sp>
+      <p:sp>
+        <p:nvSpPr>
+          <p:cNvPr id="6" name="Shape 4"/>
+          <p:cNvSpPr/>
+          <p:nvPr/>
+        </p:nvSpPr>
+        <p:spPr>
+          <a:xfrm>
+            <a:off x="0" y="6720840"/>
+            <a:ext cx="73152" cy="137160"/>
+          </a:xfrm>
+          <a:prstGeom prst="rect">
+            <a:avLst/>
+          </a:prstGeom>
+          <a:solidFill>
+            <a:srgbClr val="38BDF8"/>
+          </a:solidFill>
+          <a:ln/>
+        </p:spPr>
+      </p:sp>
+      <p:sp>
+        <p:nvSpPr>
+          <p:cNvPr id="7" name="Text 5"/>
+          <p:cNvSpPr/>
+          <p:nvPr/>
+        </p:nvSpPr>
+        <p:spPr>
+          <a:xfrm>
+            <a:off x="274320" y="6720840"/>
+            <a:ext cx="2743200" cy="137160"/>
+          </a:xfrm>
+          <a:prstGeom prst="rect">
+            <a:avLst/>
+          </a:prstGeom>
+          <a:noFill/>
+          <a:ln/>
+        </p:spPr>
+        <p:txBody>
+          <a:bodyPr wrap="square" rtlCol="0" anchor="ctr"/>
+          <a:lstStyle/>
+          <a:p>
+            <a:pPr indent="0" marL="0">
+              <a:buNone/>
+            </a:pPr>
+            <a:r>
+              <a:rPr lang="en-US" sz="1000" dirty="0">
+                <a:solidFill>
+                  <a:srgbClr val="6B7280"/>
+                </a:solidFill>
+                <a:latin typeface="Calibri" pitchFamily="34" charset="0"/>
+                <a:ea typeface="Calibri" pitchFamily="34" charset="-122"/>
+                <a:cs typeface="Calibri" pitchFamily="34" charset="-120"/>
+              </a:rPr>
+              <a:t>Creatives Takeover</a:t>
+            </a:r>
+            <a:endParaRPr lang="en-US" sz="1000" dirty="0"/>
+          </a:p>
+        </p:txBody>
+      </p:sp>
+      <p:sp>
+        <p:nvSpPr>
+          <p:cNvPr id="8" name="Text 6"/>
+          <p:cNvSpPr/>
+          <p:nvPr/>
+        </p:nvSpPr>
+        <p:spPr>
+          <a:xfrm>
+            <a:off x="8412480" y="6720840"/>
+            <a:ext cx="274320" cy="137160"/>
+          </a:xfrm>
+          <a:prstGeom prst="rect">
+            <a:avLst/>
+          </a:prstGeom>
+          <a:noFill/>
+          <a:ln/>
+        </p:spPr>
+        <p:txBody>
+          <a:bodyPr wrap="square" rtlCol="0" anchor="ctr"/>
+          <a:lstStyle/>
+          <a:p>
+            <a:pPr algn="r" indent="0" marL="0">
+              <a:buNone/>
+            </a:pPr>
+            <a:r>
+              <a:rPr lang="en-US" sz="1000" dirty="0">
+                <a:solidFill>
+                  <a:srgbClr val="6B7280"/>
+                </a:solidFill>
+                <a:latin typeface="Calibri" pitchFamily="34" charset="0"/>
+                <a:ea typeface="Calibri" pitchFamily="34" charset="-122"/>
+                <a:cs typeface="Calibri" pitchFamily="34" charset="-120"/>
+              </a:rPr>
+              <a:t>10</a:t>
+            </a:r>
+            <a:endParaRPr lang="en-US" sz="1000" dirty="0"/>
           </a:p>
         </p:txBody>
       </p:sp>
@@ -2415,6 +2387,13 @@
 <file path=ppt/slides/slide11.xml><?xml version="1.0" encoding="utf-8"?>
 <p:sld xmlns:a="http://schemas.openxmlformats.org/drawingml/2006/main" xmlns:r="http://schemas.openxmlformats.org/officeDocument/2006/relationships" xmlns:p="http://schemas.openxmlformats.org/presentationml/2006/main">
   <p:cSld name="Slide 11">
+    <p:bg>
+      <p:bgPr>
+        <a:solidFill>
+          <a:srgbClr val="FFFFFF"/>
+        </a:solidFill>
+      </p:bgPr>
+    </p:bg>
     <p:spTree>
       <p:nvGrpSpPr>
         <p:cNvPr id="1" name=""/>
@@ -2431,14 +2410,34 @@
       </p:grpSpPr>
       <p:sp>
         <p:nvSpPr>
-          <p:cNvPr id="2" name="Text 0"/>
-          <p:cNvSpPr/>
-          <p:nvPr/>
-        </p:nvSpPr>
-        <p:spPr>
-          <a:xfrm>
-            <a:off x="457200" y="457200"/>
-            <a:ext cx="8229600" cy="685800"/>
+          <p:cNvPr id="2" name="Shape 0"/>
+          <p:cNvSpPr/>
+          <p:nvPr/>
+        </p:nvSpPr>
+        <p:spPr>
+          <a:xfrm>
+            <a:off x="0" y="0"/>
+            <a:ext cx="9144000" cy="137160"/>
+          </a:xfrm>
+          <a:prstGeom prst="rect">
+            <a:avLst/>
+          </a:prstGeom>
+          <a:solidFill>
+            <a:srgbClr val="0B1437"/>
+          </a:solidFill>
+          <a:ln/>
+        </p:spPr>
+      </p:sp>
+      <p:sp>
+        <p:nvSpPr>
+          <p:cNvPr id="3" name="Text 1"/>
+          <p:cNvSpPr/>
+          <p:nvPr/>
+        </p:nvSpPr>
+        <p:spPr>
+          <a:xfrm>
+            <a:off x="457200" y="365760"/>
+            <a:ext cx="8229600" cy="548640"/>
           </a:xfrm>
           <a:prstGeom prst="rect">
             <a:avLst/>
@@ -2458,8 +2457,11 @@
                 <a:solidFill>
                   <a:srgbClr val="0B1437"/>
                 </a:solidFill>
-              </a:rPr>
-              <a:t>Traction</a:t>
+                <a:latin typeface="Calibri" pitchFamily="34" charset="0"/>
+                <a:ea typeface="Calibri" pitchFamily="34" charset="-122"/>
+                <a:cs typeface="Calibri" pitchFamily="34" charset="-120"/>
+              </a:rPr>
+              <a:t>Customer Results</a:t>
             </a:r>
             <a:endParaRPr lang="en-US" sz="3200" dirty="0"/>
           </a:p>
@@ -2467,7 +2469,46 @@
       </p:sp>
       <p:sp>
         <p:nvSpPr>
-          <p:cNvPr id="3" name="Text 1"/>
+          <p:cNvPr id="4" name="Text 2"/>
+          <p:cNvSpPr/>
+          <p:nvPr/>
+        </p:nvSpPr>
+        <p:spPr>
+          <a:xfrm>
+            <a:off x="457200" y="914400"/>
+            <a:ext cx="8229600" cy="365760"/>
+          </a:xfrm>
+          <a:prstGeom prst="rect">
+            <a:avLst/>
+          </a:prstGeom>
+          <a:noFill/>
+          <a:ln/>
+        </p:spPr>
+        <p:txBody>
+          <a:bodyPr wrap="square" rtlCol="0" anchor="ctr"/>
+          <a:lstStyle/>
+          <a:p>
+            <a:pPr indent="0" marL="0">
+              <a:buNone/>
+            </a:pPr>
+            <a:r>
+              <a:rPr lang="en-US" sz="1600" i="1" dirty="0">
+                <a:solidFill>
+                  <a:srgbClr val="6B7280"/>
+                </a:solidFill>
+                <a:latin typeface="Calibri" pitchFamily="34" charset="0"/>
+                <a:ea typeface="Calibri" pitchFamily="34" charset="-122"/>
+                <a:cs typeface="Calibri" pitchFamily="34" charset="-120"/>
+              </a:rPr>
+              <a:t>Real impact</a:t>
+            </a:r>
+            <a:endParaRPr lang="en-US" sz="1600" dirty="0"/>
+          </a:p>
+        </p:txBody>
+      </p:sp>
+      <p:sp>
+        <p:nvSpPr>
+          <p:cNvPr id="5" name="Text 3"/>
           <p:cNvSpPr/>
           <p:nvPr/>
         </p:nvSpPr>
@@ -2494,14 +2535,17 @@
               <a:buChar char="•"/>
             </a:pPr>
             <a:r>
-              <a:rPr lang="en-US" sz="1600" dirty="0">
-                <a:solidFill>
-                  <a:srgbClr val="374151"/>
-                </a:solidFill>
-              </a:rPr>
-              <a:t>User metrics</a:t>
-            </a:r>
-            <a:endParaRPr lang="en-US" sz="1600" dirty="0"/>
+              <a:rPr lang="en-US" sz="1800" b="1" dirty="0">
+                <a:solidFill>
+                  <a:srgbClr val="10B981"/>
+                </a:solidFill>
+                <a:latin typeface="Calibri" pitchFamily="34" charset="0"/>
+                <a:ea typeface="Calibri" pitchFamily="34" charset="-122"/>
+                <a:cs typeface="Calibri" pitchFamily="34" charset="-120"/>
+              </a:rPr>
+              <a:t>Sarah (Bakery Owner): Saved 20 hours/week, paid 2x faster</a:t>
+            </a:r>
+            <a:endParaRPr lang="en-US" sz="1800" dirty="0"/>
           </a:p>
           <a:p>
             <a:pPr marL="342900" indent="-342900">
@@ -2512,14 +2556,17 @@
               <a:buChar char="•"/>
             </a:pPr>
             <a:r>
-              <a:rPr lang="en-US" sz="1600" dirty="0">
-                <a:solidFill>
-                  <a:srgbClr val="374151"/>
-                </a:solidFill>
-              </a:rPr>
-              <a:t>Usage statistics</a:t>
-            </a:r>
-            <a:endParaRPr lang="en-US" sz="1600" dirty="0"/>
+              <a:rPr lang="en-US" sz="1800" b="1" dirty="0">
+                <a:solidFill>
+                  <a:srgbClr val="10B981"/>
+                </a:solidFill>
+                <a:latin typeface="Calibri" pitchFamily="34" charset="0"/>
+                <a:ea typeface="Calibri" pitchFamily="34" charset="-122"/>
+                <a:cs typeface="Calibri" pitchFamily="34" charset="-120"/>
+              </a:rPr>
+              <a:t>Mike (Consultant): Increased on-time payments from 60% to 95%</a:t>
+            </a:r>
+            <a:endParaRPr lang="en-US" sz="1800" dirty="0"/>
           </a:p>
           <a:p>
             <a:pPr marL="342900" indent="-342900">
@@ -2530,14 +2577,17 @@
               <a:buChar char="•"/>
             </a:pPr>
             <a:r>
-              <a:rPr lang="en-US" sz="1600" dirty="0">
-                <a:solidFill>
-                  <a:srgbClr val="374151"/>
-                </a:solidFill>
-              </a:rPr>
-              <a:t>Retention data</a:t>
-            </a:r>
-            <a:endParaRPr lang="en-US" sz="1600" dirty="0"/>
+              <a:rPr lang="en-US" sz="1800" b="1" dirty="0">
+                <a:solidFill>
+                  <a:srgbClr val="10B981"/>
+                </a:solidFill>
+                <a:latin typeface="Calibri" pitchFamily="34" charset="0"/>
+                <a:ea typeface="Calibri" pitchFamily="34" charset="-122"/>
+                <a:cs typeface="Calibri" pitchFamily="34" charset="-120"/>
+              </a:rPr>
+              <a:t>Emily (Agency): Scaled from $50K to $500K revenue without hiring an accountant</a:t>
+            </a:r>
+            <a:endParaRPr lang="en-US" sz="1800" dirty="0"/>
           </a:p>
           <a:p>
             <a:pPr marL="342900" indent="-342900">
@@ -2548,14 +2598,115 @@
               <a:buChar char="•"/>
             </a:pPr>
             <a:r>
-              <a:rPr lang="en-US" sz="1600" dirty="0">
-                <a:solidFill>
-                  <a:srgbClr val="374151"/>
-                </a:solidFill>
-              </a:rPr>
-              <a:t>Customer feedback</a:t>
-            </a:r>
-            <a:endParaRPr lang="en-US" sz="1600" dirty="0"/>
+              <a:rPr lang="en-US" sz="1800" b="1" dirty="0">
+                <a:solidFill>
+                  <a:srgbClr val="1F2937"/>
+                </a:solidFill>
+                <a:latin typeface="Calibri" pitchFamily="34" charset="0"/>
+                <a:ea typeface="Calibri" pitchFamily="34" charset="-122"/>
+                <a:cs typeface="Calibri" pitchFamily="34" charset="-120"/>
+              </a:rPr>
+              <a:t>Average customer saves $50K annually</a:t>
+            </a:r>
+            <a:endParaRPr lang="en-US" sz="1800" dirty="0"/>
+          </a:p>
+        </p:txBody>
+      </p:sp>
+      <p:sp>
+        <p:nvSpPr>
+          <p:cNvPr id="6" name="Shape 4"/>
+          <p:cNvSpPr/>
+          <p:nvPr/>
+        </p:nvSpPr>
+        <p:spPr>
+          <a:xfrm>
+            <a:off x="0" y="6720840"/>
+            <a:ext cx="73152" cy="137160"/>
+          </a:xfrm>
+          <a:prstGeom prst="rect">
+            <a:avLst/>
+          </a:prstGeom>
+          <a:solidFill>
+            <a:srgbClr val="38BDF8"/>
+          </a:solidFill>
+          <a:ln/>
+        </p:spPr>
+      </p:sp>
+      <p:sp>
+        <p:nvSpPr>
+          <p:cNvPr id="7" name="Text 5"/>
+          <p:cNvSpPr/>
+          <p:nvPr/>
+        </p:nvSpPr>
+        <p:spPr>
+          <a:xfrm>
+            <a:off x="274320" y="6720840"/>
+            <a:ext cx="2743200" cy="137160"/>
+          </a:xfrm>
+          <a:prstGeom prst="rect">
+            <a:avLst/>
+          </a:prstGeom>
+          <a:noFill/>
+          <a:ln/>
+        </p:spPr>
+        <p:txBody>
+          <a:bodyPr wrap="square" rtlCol="0" anchor="ctr"/>
+          <a:lstStyle/>
+          <a:p>
+            <a:pPr indent="0" marL="0">
+              <a:buNone/>
+            </a:pPr>
+            <a:r>
+              <a:rPr lang="en-US" sz="1000" dirty="0">
+                <a:solidFill>
+                  <a:srgbClr val="6B7280"/>
+                </a:solidFill>
+                <a:latin typeface="Calibri" pitchFamily="34" charset="0"/>
+                <a:ea typeface="Calibri" pitchFamily="34" charset="-122"/>
+                <a:cs typeface="Calibri" pitchFamily="34" charset="-120"/>
+              </a:rPr>
+              <a:t>Creatives Takeover</a:t>
+            </a:r>
+            <a:endParaRPr lang="en-US" sz="1000" dirty="0"/>
+          </a:p>
+        </p:txBody>
+      </p:sp>
+      <p:sp>
+        <p:nvSpPr>
+          <p:cNvPr id="8" name="Text 6"/>
+          <p:cNvSpPr/>
+          <p:nvPr/>
+        </p:nvSpPr>
+        <p:spPr>
+          <a:xfrm>
+            <a:off x="8412480" y="6720840"/>
+            <a:ext cx="274320" cy="137160"/>
+          </a:xfrm>
+          <a:prstGeom prst="rect">
+            <a:avLst/>
+          </a:prstGeom>
+          <a:noFill/>
+          <a:ln/>
+        </p:spPr>
+        <p:txBody>
+          <a:bodyPr wrap="square" rtlCol="0" anchor="ctr"/>
+          <a:lstStyle/>
+          <a:p>
+            <a:pPr algn="r" indent="0" marL="0">
+              <a:buNone/>
+            </a:pPr>
+            <a:r>
+              <a:rPr lang="en-US" sz="1000" dirty="0">
+                <a:solidFill>
+                  <a:srgbClr val="6B7280"/>
+                </a:solidFill>
+                <a:latin typeface="Calibri" pitchFamily="34" charset="0"/>
+                <a:ea typeface="Calibri" pitchFamily="34" charset="-122"/>
+                <a:cs typeface="Calibri" pitchFamily="34" charset="-120"/>
+              </a:rPr>
+              <a:t>11</a:t>
+            </a:r>
+            <a:endParaRPr lang="en-US" sz="1000" dirty="0"/>
           </a:p>
         </p:txBody>
       </p:sp>
@@ -2570,6 +2721,13 @@
 <file path=ppt/slides/slide12.xml><?xml version="1.0" encoding="utf-8"?>
 <p:sld xmlns:a="http://schemas.openxmlformats.org/drawingml/2006/main" xmlns:r="http://schemas.openxmlformats.org/officeDocument/2006/relationships" xmlns:p="http://schemas.openxmlformats.org/presentationml/2006/main">
   <p:cSld name="Slide 12">
+    <p:bg>
+      <p:bgPr>
+        <a:solidFill>
+          <a:srgbClr val="FFFFFF"/>
+        </a:solidFill>
+      </p:bgPr>
+    </p:bg>
     <p:spTree>
       <p:nvGrpSpPr>
         <p:cNvPr id="1" name=""/>
@@ -2586,14 +2744,34 @@
       </p:grpSpPr>
       <p:sp>
         <p:nvSpPr>
-          <p:cNvPr id="2" name="Text 0"/>
-          <p:cNvSpPr/>
-          <p:nvPr/>
-        </p:nvSpPr>
-        <p:spPr>
-          <a:xfrm>
-            <a:off x="457200" y="457200"/>
-            <a:ext cx="8229600" cy="685800"/>
+          <p:cNvPr id="2" name="Shape 0"/>
+          <p:cNvSpPr/>
+          <p:nvPr/>
+        </p:nvSpPr>
+        <p:spPr>
+          <a:xfrm>
+            <a:off x="0" y="0"/>
+            <a:ext cx="9144000" cy="137160"/>
+          </a:xfrm>
+          <a:prstGeom prst="rect">
+            <a:avLst/>
+          </a:prstGeom>
+          <a:solidFill>
+            <a:srgbClr val="0B1437"/>
+          </a:solidFill>
+          <a:ln/>
+        </p:spPr>
+      </p:sp>
+      <p:sp>
+        <p:nvSpPr>
+          <p:cNvPr id="3" name="Text 1"/>
+          <p:cNvSpPr/>
+          <p:nvPr/>
+        </p:nvSpPr>
+        <p:spPr>
+          <a:xfrm>
+            <a:off x="457200" y="365760"/>
+            <a:ext cx="8229600" cy="548640"/>
           </a:xfrm>
           <a:prstGeom prst="rect">
             <a:avLst/>
@@ -2613,8 +2791,11 @@
                 <a:solidFill>
                   <a:srgbClr val="0B1437"/>
                 </a:solidFill>
-              </a:rPr>
-              <a:t>Roadmap</a:t>
+                <a:latin typeface="Calibri" pitchFamily="34" charset="0"/>
+                <a:ea typeface="Calibri" pitchFamily="34" charset="-122"/>
+                <a:cs typeface="Calibri" pitchFamily="34" charset="-120"/>
+              </a:rPr>
+              <a:t>Business Model</a:t>
             </a:r>
             <a:endParaRPr lang="en-US" sz="3200" dirty="0"/>
           </a:p>
@@ -2622,7 +2803,46 @@
       </p:sp>
       <p:sp>
         <p:nvSpPr>
-          <p:cNvPr id="3" name="Text 1"/>
+          <p:cNvPr id="4" name="Text 2"/>
+          <p:cNvSpPr/>
+          <p:nvPr/>
+        </p:nvSpPr>
+        <p:spPr>
+          <a:xfrm>
+            <a:off x="457200" y="914400"/>
+            <a:ext cx="8229600" cy="365760"/>
+          </a:xfrm>
+          <a:prstGeom prst="rect">
+            <a:avLst/>
+          </a:prstGeom>
+          <a:noFill/>
+          <a:ln/>
+        </p:spPr>
+        <p:txBody>
+          <a:bodyPr wrap="square" rtlCol="0" anchor="ctr"/>
+          <a:lstStyle/>
+          <a:p>
+            <a:pPr indent="0" marL="0">
+              <a:buNone/>
+            </a:pPr>
+            <a:r>
+              <a:rPr lang="en-US" sz="1600" i="1" dirty="0">
+                <a:solidFill>
+                  <a:srgbClr val="6B7280"/>
+                </a:solidFill>
+                <a:latin typeface="Calibri" pitchFamily="34" charset="0"/>
+                <a:ea typeface="Calibri" pitchFamily="34" charset="-122"/>
+                <a:cs typeface="Calibri" pitchFamily="34" charset="-120"/>
+              </a:rPr>
+              <a:t>Simple, transparent pricing</a:t>
+            </a:r>
+            <a:endParaRPr lang="en-US" sz="1600" dirty="0"/>
+          </a:p>
+        </p:txBody>
+      </p:sp>
+      <p:sp>
+        <p:nvSpPr>
+          <p:cNvPr id="5" name="Text 3"/>
           <p:cNvSpPr/>
           <p:nvPr/>
         </p:nvSpPr>
@@ -2649,14 +2869,17 @@
               <a:buChar char="•"/>
             </a:pPr>
             <a:r>
-              <a:rPr lang="en-US" sz="1600" dirty="0">
-                <a:solidFill>
-                  <a:srgbClr val="374151"/>
-                </a:solidFill>
-              </a:rPr>
-              <a:t>Upcoming features</a:t>
-            </a:r>
-            <a:endParaRPr lang="en-US" sz="1600" dirty="0"/>
+              <a:rPr lang="en-US" sz="1800" b="1" dirty="0">
+                <a:solidFill>
+                  <a:srgbClr val="1F2937"/>
+                </a:solidFill>
+                <a:latin typeface="Calibri" pitchFamily="34" charset="0"/>
+                <a:ea typeface="Calibri" pitchFamily="34" charset="-122"/>
+                <a:cs typeface="Calibri" pitchFamily="34" charset="-120"/>
+              </a:rPr>
+              <a:t>Starter: $29/month (1 user, 50 invoices/month)</a:t>
+            </a:r>
+            <a:endParaRPr lang="en-US" sz="1800" dirty="0"/>
           </a:p>
           <a:p>
             <a:pPr marL="342900" indent="-342900">
@@ -2667,14 +2890,17 @@
               <a:buChar char="•"/>
             </a:pPr>
             <a:r>
-              <a:rPr lang="en-US" sz="1600" dirty="0">
-                <a:solidFill>
-                  <a:srgbClr val="374151"/>
-                </a:solidFill>
-              </a:rPr>
-              <a:t>Product expansion</a:t>
-            </a:r>
-            <a:endParaRPr lang="en-US" sz="1600" dirty="0"/>
+              <a:rPr lang="en-US" sz="1800" b="1" dirty="0">
+                <a:solidFill>
+                  <a:srgbClr val="1F2937"/>
+                </a:solidFill>
+                <a:latin typeface="Calibri" pitchFamily="34" charset="0"/>
+                <a:ea typeface="Calibri" pitchFamily="34" charset="-122"/>
+                <a:cs typeface="Calibri" pitchFamily="34" charset="-120"/>
+              </a:rPr>
+              <a:t>Professional: $79/month (5 users, unlimited invoices)</a:t>
+            </a:r>
+            <a:endParaRPr lang="en-US" sz="1800" dirty="0"/>
           </a:p>
           <a:p>
             <a:pPr marL="342900" indent="-342900">
@@ -2685,14 +2911,17 @@
               <a:buChar char="•"/>
             </a:pPr>
             <a:r>
-              <a:rPr lang="en-US" sz="1600" dirty="0">
-                <a:solidFill>
-                  <a:srgbClr val="374151"/>
-                </a:solidFill>
-              </a:rPr>
-              <a:t>Platform vision</a:t>
-            </a:r>
-            <a:endParaRPr lang="en-US" sz="1600" dirty="0"/>
+              <a:rPr lang="en-US" sz="1800" b="1" dirty="0">
+                <a:solidFill>
+                  <a:srgbClr val="1F2937"/>
+                </a:solidFill>
+                <a:latin typeface="Calibri" pitchFamily="34" charset="0"/>
+                <a:ea typeface="Calibri" pitchFamily="34" charset="-122"/>
+                <a:cs typeface="Calibri" pitchFamily="34" charset="-120"/>
+              </a:rPr>
+              <a:t>Enterprise: Custom pricing (unlimited users, dedicated support)</a:t>
+            </a:r>
+            <a:endParaRPr lang="en-US" sz="1800" dirty="0"/>
           </a:p>
           <a:p>
             <a:pPr marL="342900" indent="-342900">
@@ -2703,14 +2932,136 @@
               <a:buChar char="•"/>
             </a:pPr>
             <a:r>
-              <a:rPr lang="en-US" sz="1600" dirty="0">
-                <a:solidFill>
-                  <a:srgbClr val="374151"/>
-                </a:solidFill>
-              </a:rPr>
-              <a:t>Timeline</a:t>
-            </a:r>
-            <a:endParaRPr lang="en-US" sz="1600" dirty="0"/>
+              <a:rPr lang="en-US" sz="1800" b="1" dirty="0">
+                <a:solidFill>
+                  <a:srgbClr val="1F2937"/>
+                </a:solidFill>
+                <a:latin typeface="Calibri" pitchFamily="34" charset="0"/>
+                <a:ea typeface="Calibri" pitchFamily="34" charset="-122"/>
+                <a:cs typeface="Calibri" pitchFamily="34" charset="-120"/>
+              </a:rPr>
+              <a:t>No setup fees, cancel anytime</a:t>
+            </a:r>
+            <a:endParaRPr lang="en-US" sz="1800" dirty="0"/>
+          </a:p>
+          <a:p>
+            <a:pPr marL="342900" indent="-342900">
+              <a:lnSpc>
+                <a:spcPts val="2800"/>
+              </a:lnSpc>
+              <a:buSzPct val="100000"/>
+              <a:buChar char="•"/>
+            </a:pPr>
+            <a:r>
+              <a:rPr lang="en-US" sz="1800" b="1" dirty="0">
+                <a:solidFill>
+                  <a:srgbClr val="10B981"/>
+                </a:solidFill>
+                <a:latin typeface="Calibri" pitchFamily="34" charset="0"/>
+                <a:ea typeface="Calibri" pitchFamily="34" charset="-122"/>
+                <a:cs typeface="Calibri" pitchFamily="34" charset="-120"/>
+              </a:rPr>
+              <a:t>ROI Calculator: $29/month saves you $4,000/month in time and late fees</a:t>
+            </a:r>
+            <a:endParaRPr lang="en-US" sz="1800" dirty="0"/>
+          </a:p>
+        </p:txBody>
+      </p:sp>
+      <p:sp>
+        <p:nvSpPr>
+          <p:cNvPr id="6" name="Shape 4"/>
+          <p:cNvSpPr/>
+          <p:nvPr/>
+        </p:nvSpPr>
+        <p:spPr>
+          <a:xfrm>
+            <a:off x="0" y="6720840"/>
+            <a:ext cx="73152" cy="137160"/>
+          </a:xfrm>
+          <a:prstGeom prst="rect">
+            <a:avLst/>
+          </a:prstGeom>
+          <a:solidFill>
+            <a:srgbClr val="38BDF8"/>
+          </a:solidFill>
+          <a:ln/>
+        </p:spPr>
+      </p:sp>
+      <p:sp>
+        <p:nvSpPr>
+          <p:cNvPr id="7" name="Text 5"/>
+          <p:cNvSpPr/>
+          <p:nvPr/>
+        </p:nvSpPr>
+        <p:spPr>
+          <a:xfrm>
+            <a:off x="274320" y="6720840"/>
+            <a:ext cx="2743200" cy="137160"/>
+          </a:xfrm>
+          <a:prstGeom prst="rect">
+            <a:avLst/>
+          </a:prstGeom>
+          <a:noFill/>
+          <a:ln/>
+        </p:spPr>
+        <p:txBody>
+          <a:bodyPr wrap="square" rtlCol="0" anchor="ctr"/>
+          <a:lstStyle/>
+          <a:p>
+            <a:pPr indent="0" marL="0">
+              <a:buNone/>
+            </a:pPr>
+            <a:r>
+              <a:rPr lang="en-US" sz="1000" dirty="0">
+                <a:solidFill>
+                  <a:srgbClr val="6B7280"/>
+                </a:solidFill>
+                <a:latin typeface="Calibri" pitchFamily="34" charset="0"/>
+                <a:ea typeface="Calibri" pitchFamily="34" charset="-122"/>
+                <a:cs typeface="Calibri" pitchFamily="34" charset="-120"/>
+              </a:rPr>
+              <a:t>Creatives Takeover</a:t>
+            </a:r>
+            <a:endParaRPr lang="en-US" sz="1000" dirty="0"/>
+          </a:p>
+        </p:txBody>
+      </p:sp>
+      <p:sp>
+        <p:nvSpPr>
+          <p:cNvPr id="8" name="Text 6"/>
+          <p:cNvSpPr/>
+          <p:nvPr/>
+        </p:nvSpPr>
+        <p:spPr>
+          <a:xfrm>
+            <a:off x="8412480" y="6720840"/>
+            <a:ext cx="274320" cy="137160"/>
+          </a:xfrm>
+          <a:prstGeom prst="rect">
+            <a:avLst/>
+          </a:prstGeom>
+          <a:noFill/>
+          <a:ln/>
+        </p:spPr>
+        <p:txBody>
+          <a:bodyPr wrap="square" rtlCol="0" anchor="ctr"/>
+          <a:lstStyle/>
+          <a:p>
+            <a:pPr algn="r" indent="0" marL="0">
+              <a:buNone/>
+            </a:pPr>
+            <a:r>
+              <a:rPr lang="en-US" sz="1000" dirty="0">
+                <a:solidFill>
+                  <a:srgbClr val="6B7280"/>
+                </a:solidFill>
+                <a:latin typeface="Calibri" pitchFamily="34" charset="0"/>
+                <a:ea typeface="Calibri" pitchFamily="34" charset="-122"/>
+                <a:cs typeface="Calibri" pitchFamily="34" charset="-120"/>
+              </a:rPr>
+              <a:t>12</a:t>
+            </a:r>
+            <a:endParaRPr lang="en-US" sz="1000" dirty="0"/>
           </a:p>
         </p:txBody>
       </p:sp>
@@ -2725,6 +3076,13 @@
 <file path=ppt/slides/slide13.xml><?xml version="1.0" encoding="utf-8"?>
 <p:sld xmlns:a="http://schemas.openxmlformats.org/drawingml/2006/main" xmlns:r="http://schemas.openxmlformats.org/officeDocument/2006/relationships" xmlns:p="http://schemas.openxmlformats.org/presentationml/2006/main">
   <p:cSld name="Slide 13">
+    <p:bg>
+      <p:bgPr>
+        <a:solidFill>
+          <a:srgbClr val="FFFFFF"/>
+        </a:solidFill>
+      </p:bgPr>
+    </p:bg>
     <p:spTree>
       <p:nvGrpSpPr>
         <p:cNvPr id="1" name=""/>
@@ -2741,14 +3099,34 @@
       </p:grpSpPr>
       <p:sp>
         <p:nvSpPr>
-          <p:cNvPr id="2" name="Text 0"/>
-          <p:cNvSpPr/>
-          <p:nvPr/>
-        </p:nvSpPr>
-        <p:spPr>
-          <a:xfrm>
-            <a:off x="457200" y="457200"/>
-            <a:ext cx="8229600" cy="685800"/>
+          <p:cNvPr id="2" name="Shape 0"/>
+          <p:cNvSpPr/>
+          <p:nvPr/>
+        </p:nvSpPr>
+        <p:spPr>
+          <a:xfrm>
+            <a:off x="0" y="0"/>
+            <a:ext cx="9144000" cy="137160"/>
+          </a:xfrm>
+          <a:prstGeom prst="rect">
+            <a:avLst/>
+          </a:prstGeom>
+          <a:solidFill>
+            <a:srgbClr val="0B1437"/>
+          </a:solidFill>
+          <a:ln/>
+        </p:spPr>
+      </p:sp>
+      <p:sp>
+        <p:nvSpPr>
+          <p:cNvPr id="3" name="Text 1"/>
+          <p:cNvSpPr/>
+          <p:nvPr/>
+        </p:nvSpPr>
+        <p:spPr>
+          <a:xfrm>
+            <a:off x="457200" y="365760"/>
+            <a:ext cx="8229600" cy="548640"/>
           </a:xfrm>
           <a:prstGeom prst="rect">
             <a:avLst/>
@@ -2768,8 +3146,11 @@
                 <a:solidFill>
                   <a:srgbClr val="0B1437"/>
                 </a:solidFill>
-              </a:rPr>
-              <a:t>Team</a:t>
+                <a:latin typeface="Calibri" pitchFamily="34" charset="0"/>
+                <a:ea typeface="Calibri" pitchFamily="34" charset="-122"/>
+                <a:cs typeface="Calibri" pitchFamily="34" charset="-120"/>
+              </a:rPr>
+              <a:t>The Ask</a:t>
             </a:r>
             <a:endParaRPr lang="en-US" sz="3200" dirty="0"/>
           </a:p>
@@ -2777,7 +3158,46 @@
       </p:sp>
       <p:sp>
         <p:nvSpPr>
-          <p:cNvPr id="3" name="Text 1"/>
+          <p:cNvPr id="4" name="Text 2"/>
+          <p:cNvSpPr/>
+          <p:nvPr/>
+        </p:nvSpPr>
+        <p:spPr>
+          <a:xfrm>
+            <a:off x="457200" y="914400"/>
+            <a:ext cx="8229600" cy="365760"/>
+          </a:xfrm>
+          <a:prstGeom prst="rect">
+            <a:avLst/>
+          </a:prstGeom>
+          <a:noFill/>
+          <a:ln/>
+        </p:spPr>
+        <p:txBody>
+          <a:bodyPr wrap="square" rtlCol="0" anchor="ctr"/>
+          <a:lstStyle/>
+          <a:p>
+            <a:pPr indent="0" marL="0">
+              <a:buNone/>
+            </a:pPr>
+            <a:r>
+              <a:rPr lang="en-US" sz="1600" i="1" dirty="0">
+                <a:solidFill>
+                  <a:srgbClr val="6B7280"/>
+                </a:solidFill>
+                <a:latin typeface="Calibri" pitchFamily="34" charset="0"/>
+                <a:ea typeface="Calibri" pitchFamily="34" charset="-122"/>
+                <a:cs typeface="Calibri" pitchFamily="34" charset="-120"/>
+              </a:rPr>
+              <a:t>Join us in transforming SMB finance</a:t>
+            </a:r>
+            <a:endParaRPr lang="en-US" sz="1600" dirty="0"/>
+          </a:p>
+        </p:txBody>
+      </p:sp>
+      <p:sp>
+        <p:nvSpPr>
+          <p:cNvPr id="5" name="Text 3"/>
           <p:cNvSpPr/>
           <p:nvPr/>
         </p:nvSpPr>
@@ -2804,14 +3224,17 @@
               <a:buChar char="•"/>
             </a:pPr>
             <a:r>
-              <a:rPr lang="en-US" sz="1600" dirty="0">
-                <a:solidFill>
-                  <a:srgbClr val="374151"/>
-                </a:solidFill>
-              </a:rPr>
-              <a:t>Technical founders</a:t>
-            </a:r>
-            <a:endParaRPr lang="en-US" sz="1600" dirty="0"/>
+              <a:rPr lang="en-US" sz="2400" b="1" dirty="0">
+                <a:solidFill>
+                  <a:srgbClr val="0B1437"/>
+                </a:solidFill>
+                <a:latin typeface="Calibri" pitchFamily="34" charset="0"/>
+                <a:ea typeface="Calibri" pitchFamily="34" charset="-122"/>
+                <a:cs typeface="Calibri" pitchFamily="34" charset="-120"/>
+              </a:rPr>
+              <a:t>Raising $2M Seed to scale product and customer base</a:t>
+            </a:r>
+            <a:endParaRPr lang="en-US" sz="2400" dirty="0"/>
           </a:p>
           <a:p>
             <a:pPr marL="342900" indent="-342900">
@@ -2822,14 +3245,80 @@
               <a:buChar char="•"/>
             </a:pPr>
             <a:r>
-              <a:rPr lang="en-US" sz="1600" dirty="0">
-                <a:solidFill>
-                  <a:srgbClr val="374151"/>
-                </a:solidFill>
-              </a:rPr>
-              <a:t>Product expertise</a:t>
-            </a:r>
-            <a:endParaRPr lang="en-US" sz="1600" dirty="0"/>
+              <a:rPr lang="en-US" sz="1800" b="1" dirty="0">
+                <a:solidFill>
+                  <a:srgbClr val="1F2937"/>
+                </a:solidFill>
+                <a:latin typeface="Calibri" pitchFamily="34" charset="0"/>
+                <a:ea typeface="Calibri" pitchFamily="34" charset="-122"/>
+                <a:cs typeface="Calibri" pitchFamily="34" charset="-120"/>
+              </a:rPr>
+              <a:t>Use of Funds:</a:t>
+            </a:r>
+            <a:endParaRPr lang="en-US" sz="2400" dirty="0"/>
+          </a:p>
+          <a:p>
+            <a:pPr lvl="1" marL="685800" indent="-342900">
+              <a:lnSpc>
+                <a:spcPts val="2800"/>
+              </a:lnSpc>
+              <a:buSzPct val="100000"/>
+              <a:buChar char="•"/>
+            </a:pPr>
+            <a:r>
+              <a:rPr lang="en-US" sz="1800" dirty="0">
+                <a:solidFill>
+                  <a:srgbClr val="6B7280"/>
+                </a:solidFill>
+                <a:latin typeface="Calibri" pitchFamily="34" charset="0"/>
+                <a:ea typeface="Calibri" pitchFamily="34" charset="-122"/>
+                <a:cs typeface="Calibri" pitchFamily="34" charset="-120"/>
+              </a:rPr>
+              <a:t>50% - Product development (mobile app, advanced AI features)</a:t>
+            </a:r>
+            <a:endParaRPr lang="en-US" sz="2400" dirty="0"/>
+          </a:p>
+          <a:p>
+            <a:pPr lvl="1" marL="685800" indent="-342900">
+              <a:lnSpc>
+                <a:spcPts val="2800"/>
+              </a:lnSpc>
+              <a:buSzPct val="100000"/>
+              <a:buChar char="•"/>
+            </a:pPr>
+            <a:r>
+              <a:rPr lang="en-US" sz="1800" dirty="0">
+                <a:solidFill>
+                  <a:srgbClr val="6B7280"/>
+                </a:solidFill>
+                <a:latin typeface="Calibri" pitchFamily="34" charset="0"/>
+                <a:ea typeface="Calibri" pitchFamily="34" charset="-122"/>
+                <a:cs typeface="Calibri" pitchFamily="34" charset="-120"/>
+              </a:rPr>
+              <a:t>30% - Customer acquisition (paid marketing, partnerships)</a:t>
+            </a:r>
+            <a:endParaRPr lang="en-US" sz="2400" dirty="0"/>
+          </a:p>
+          <a:p>
+            <a:pPr lvl="1" marL="685800" indent="-342900">
+              <a:lnSpc>
+                <a:spcPts val="2800"/>
+              </a:lnSpc>
+              <a:buSzPct val="100000"/>
+              <a:buChar char="•"/>
+            </a:pPr>
+            <a:r>
+              <a:rPr lang="en-US" sz="1800" dirty="0">
+                <a:solidFill>
+                  <a:srgbClr val="6B7280"/>
+                </a:solidFill>
+                <a:latin typeface="Calibri" pitchFamily="34" charset="0"/>
+                <a:ea typeface="Calibri" pitchFamily="34" charset="-122"/>
+                <a:cs typeface="Calibri" pitchFamily="34" charset="-120"/>
+              </a:rPr>
+              <a:t>20% - Team expansion (hire 5 engineers, 2 salespeople)</a:t>
+            </a:r>
+            <a:endParaRPr lang="en-US" sz="2400" dirty="0"/>
           </a:p>
           <a:p>
             <a:pPr marL="342900" indent="-342900">
@@ -2840,14 +3329,115 @@
               <a:buChar char="•"/>
             </a:pPr>
             <a:r>
-              <a:rPr lang="en-US" sz="1600" dirty="0">
-                <a:solidFill>
-                  <a:srgbClr val="374151"/>
-                </a:solidFill>
-              </a:rPr>
-              <a:t>Previous products built</a:t>
-            </a:r>
-            <a:endParaRPr lang="en-US" sz="1600" dirty="0"/>
+              <a:rPr lang="en-US" sz="1800" b="1" dirty="0">
+                <a:solidFill>
+                  <a:srgbClr val="1F2937"/>
+                </a:solidFill>
+                <a:latin typeface="Calibri" pitchFamily="34" charset="0"/>
+                <a:ea typeface="Calibri" pitchFamily="34" charset="-122"/>
+                <a:cs typeface="Calibri" pitchFamily="34" charset="-120"/>
+              </a:rPr>
+              <a:t>18-month goal: $1M ARR, 2,000 paying customers</a:t>
+            </a:r>
+            <a:endParaRPr lang="en-US" sz="2400" dirty="0"/>
+          </a:p>
+        </p:txBody>
+      </p:sp>
+      <p:sp>
+        <p:nvSpPr>
+          <p:cNvPr id="6" name="Shape 4"/>
+          <p:cNvSpPr/>
+          <p:nvPr/>
+        </p:nvSpPr>
+        <p:spPr>
+          <a:xfrm>
+            <a:off x="0" y="6720840"/>
+            <a:ext cx="73152" cy="137160"/>
+          </a:xfrm>
+          <a:prstGeom prst="rect">
+            <a:avLst/>
+          </a:prstGeom>
+          <a:solidFill>
+            <a:srgbClr val="38BDF8"/>
+          </a:solidFill>
+          <a:ln/>
+        </p:spPr>
+      </p:sp>
+      <p:sp>
+        <p:nvSpPr>
+          <p:cNvPr id="7" name="Text 5"/>
+          <p:cNvSpPr/>
+          <p:nvPr/>
+        </p:nvSpPr>
+        <p:spPr>
+          <a:xfrm>
+            <a:off x="274320" y="6720840"/>
+            <a:ext cx="2743200" cy="137160"/>
+          </a:xfrm>
+          <a:prstGeom prst="rect">
+            <a:avLst/>
+          </a:prstGeom>
+          <a:noFill/>
+          <a:ln/>
+        </p:spPr>
+        <p:txBody>
+          <a:bodyPr wrap="square" rtlCol="0" anchor="ctr"/>
+          <a:lstStyle/>
+          <a:p>
+            <a:pPr indent="0" marL="0">
+              <a:buNone/>
+            </a:pPr>
+            <a:r>
+              <a:rPr lang="en-US" sz="1000" dirty="0">
+                <a:solidFill>
+                  <a:srgbClr val="6B7280"/>
+                </a:solidFill>
+                <a:latin typeface="Calibri" pitchFamily="34" charset="0"/>
+                <a:ea typeface="Calibri" pitchFamily="34" charset="-122"/>
+                <a:cs typeface="Calibri" pitchFamily="34" charset="-120"/>
+              </a:rPr>
+              <a:t>Creatives Takeover</a:t>
+            </a:r>
+            <a:endParaRPr lang="en-US" sz="1000" dirty="0"/>
+          </a:p>
+        </p:txBody>
+      </p:sp>
+      <p:sp>
+        <p:nvSpPr>
+          <p:cNvPr id="8" name="Text 6"/>
+          <p:cNvSpPr/>
+          <p:nvPr/>
+        </p:nvSpPr>
+        <p:spPr>
+          <a:xfrm>
+            <a:off x="8412480" y="6720840"/>
+            <a:ext cx="274320" cy="137160"/>
+          </a:xfrm>
+          <a:prstGeom prst="rect">
+            <a:avLst/>
+          </a:prstGeom>
+          <a:noFill/>
+          <a:ln/>
+        </p:spPr>
+        <p:txBody>
+          <a:bodyPr wrap="square" rtlCol="0" anchor="ctr"/>
+          <a:lstStyle/>
+          <a:p>
+            <a:pPr algn="r" indent="0" marL="0">
+              <a:buNone/>
+            </a:pPr>
+            <a:r>
+              <a:rPr lang="en-US" sz="1000" dirty="0">
+                <a:solidFill>
+                  <a:srgbClr val="6B7280"/>
+                </a:solidFill>
+                <a:latin typeface="Calibri" pitchFamily="34" charset="0"/>
+                <a:ea typeface="Calibri" pitchFamily="34" charset="-122"/>
+                <a:cs typeface="Calibri" pitchFamily="34" charset="-120"/>
+              </a:rPr>
+              <a:t>13</a:t>
+            </a:r>
+            <a:endParaRPr lang="en-US" sz="1000" dirty="0"/>
           </a:p>
         </p:txBody>
       </p:sp>
@@ -2859,9 +3449,16 @@
 </p:sld>
 </file>
 
-<file path=ppt/slides/slide14.xml><?xml version="1.0" encoding="utf-8"?>
+<file path=ppt/slides/slide2.xml><?xml version="1.0" encoding="utf-8"?>
 <p:sld xmlns:a="http://schemas.openxmlformats.org/drawingml/2006/main" xmlns:r="http://schemas.openxmlformats.org/officeDocument/2006/relationships" xmlns:p="http://schemas.openxmlformats.org/presentationml/2006/main">
-  <p:cSld name="Slide 14">
+  <p:cSld name="Slide 2">
+    <p:bg>
+      <p:bgPr>
+        <a:solidFill>
+          <a:srgbClr val="FFFFFF"/>
+        </a:solidFill>
+      </p:bgPr>
+    </p:bg>
     <p:spTree>
       <p:nvGrpSpPr>
         <p:cNvPr id="1" name=""/>
@@ -2878,14 +3475,34 @@
       </p:grpSpPr>
       <p:sp>
         <p:nvSpPr>
-          <p:cNvPr id="2" name="Text 0"/>
-          <p:cNvSpPr/>
-          <p:nvPr/>
-        </p:nvSpPr>
-        <p:spPr>
-          <a:xfrm>
-            <a:off x="457200" y="457200"/>
-            <a:ext cx="8229600" cy="685800"/>
+          <p:cNvPr id="2" name="Shape 0"/>
+          <p:cNvSpPr/>
+          <p:nvPr/>
+        </p:nvSpPr>
+        <p:spPr>
+          <a:xfrm>
+            <a:off x="0" y="0"/>
+            <a:ext cx="9144000" cy="137160"/>
+          </a:xfrm>
+          <a:prstGeom prst="rect">
+            <a:avLst/>
+          </a:prstGeom>
+          <a:solidFill>
+            <a:srgbClr val="0B1437"/>
+          </a:solidFill>
+          <a:ln/>
+        </p:spPr>
+      </p:sp>
+      <p:sp>
+        <p:nvSpPr>
+          <p:cNvPr id="3" name="Text 1"/>
+          <p:cNvSpPr/>
+          <p:nvPr/>
+        </p:nvSpPr>
+        <p:spPr>
+          <a:xfrm>
+            <a:off x="457200" y="365760"/>
+            <a:ext cx="8229600" cy="548640"/>
           </a:xfrm>
           <a:prstGeom prst="rect">
             <a:avLst/>
@@ -2905,8 +3522,11 @@
                 <a:solidFill>
                   <a:srgbClr val="0B1437"/>
                 </a:solidFill>
-              </a:rPr>
-              <a:t>Ask</a:t>
+                <a:latin typeface="Calibri" pitchFamily="34" charset="0"/>
+                <a:ea typeface="Calibri" pitchFamily="34" charset="-122"/>
+                <a:cs typeface="Calibri" pitchFamily="34" charset="-120"/>
+              </a:rPr>
+              <a:t>The User Problem</a:t>
             </a:r>
             <a:endParaRPr lang="en-US" sz="3200" dirty="0"/>
           </a:p>
@@ -2914,7 +3534,46 @@
       </p:sp>
       <p:sp>
         <p:nvSpPr>
-          <p:cNvPr id="3" name="Text 1"/>
+          <p:cNvPr id="4" name="Text 2"/>
+          <p:cNvSpPr/>
+          <p:nvPr/>
+        </p:nvSpPr>
+        <p:spPr>
+          <a:xfrm>
+            <a:off x="457200" y="914400"/>
+            <a:ext cx="8229600" cy="365760"/>
+          </a:xfrm>
+          <a:prstGeom prst="rect">
+            <a:avLst/>
+          </a:prstGeom>
+          <a:noFill/>
+          <a:ln/>
+        </p:spPr>
+        <p:txBody>
+          <a:bodyPr wrap="square" rtlCol="0" anchor="ctr"/>
+          <a:lstStyle/>
+          <a:p>
+            <a:pPr indent="0" marL="0">
+              <a:buNone/>
+            </a:pPr>
+            <a:r>
+              <a:rPr lang="en-US" sz="1600" i="1" dirty="0">
+                <a:solidFill>
+                  <a:srgbClr val="6B7280"/>
+                </a:solidFill>
+                <a:latin typeface="Calibri" pitchFamily="34" charset="0"/>
+                <a:ea typeface="Calibri" pitchFamily="34" charset="-122"/>
+                <a:cs typeface="Calibri" pitchFamily="34" charset="-120"/>
+              </a:rPr>
+              <a:t>What pain are we solving?</a:t>
+            </a:r>
+            <a:endParaRPr lang="en-US" sz="1600" dirty="0"/>
+          </a:p>
+        </p:txBody>
+      </p:sp>
+      <p:sp>
+        <p:nvSpPr>
+          <p:cNvPr id="5" name="Text 3"/>
           <p:cNvSpPr/>
           <p:nvPr/>
         </p:nvSpPr>
@@ -2941,14 +3600,38 @@
               <a:buChar char="•"/>
             </a:pPr>
             <a:r>
-              <a:rPr lang="en-US" sz="1600" dirty="0">
-                <a:solidFill>
-                  <a:srgbClr val="374151"/>
-                </a:solidFill>
-              </a:rPr>
-              <a:t>Funding amount</a:t>
-            </a:r>
-            <a:endParaRPr lang="en-US" sz="1600" dirty="0"/>
+              <a:rPr lang="en-US" sz="1800" b="1" dirty="0">
+                <a:solidFill>
+                  <a:srgbClr val="1F2937"/>
+                </a:solidFill>
+                <a:latin typeface="Calibri" pitchFamily="34" charset="0"/>
+                <a:ea typeface="Calibri" pitchFamily="34" charset="-122"/>
+                <a:cs typeface="Calibri" pitchFamily="34" charset="-120"/>
+              </a:rPr>
+              <a:t>Start with the user's current painful experience</a:t>
+            </a:r>
+            <a:endParaRPr lang="en-US" sz="1800" dirty="0"/>
+          </a:p>
+          <a:p>
+            <a:pPr lvl="1" marL="685800" indent="-342900">
+              <a:lnSpc>
+                <a:spcPts val="2800"/>
+              </a:lnSpc>
+              <a:buSzPct val="100000"/>
+              <a:buChar char="•"/>
+            </a:pPr>
+            <a:r>
+              <a:rPr lang="en-US" sz="1800" dirty="0">
+                <a:solidFill>
+                  <a:srgbClr val="6B7280"/>
+                </a:solidFill>
+                <a:latin typeface="Calibri" pitchFamily="34" charset="0"/>
+                <a:ea typeface="Calibri" pitchFamily="34" charset="-122"/>
+                <a:cs typeface="Calibri" pitchFamily="34" charset="-120"/>
+              </a:rPr>
+              <a:t>Example: "Business owners waste 20 hours/week on invoicing and payment tracking"</a:t>
+            </a:r>
+            <a:endParaRPr lang="en-US" sz="1800" dirty="0"/>
           </a:p>
           <a:p>
             <a:pPr marL="342900" indent="-342900">
@@ -2959,14 +3642,17 @@
               <a:buChar char="•"/>
             </a:pPr>
             <a:r>
-              <a:rPr lang="en-US" sz="1600" dirty="0">
-                <a:solidFill>
-                  <a:srgbClr val="374151"/>
-                </a:solidFill>
-              </a:rPr>
-              <a:t>Use for product development</a:t>
-            </a:r>
-            <a:endParaRPr lang="en-US" sz="1600" dirty="0"/>
+              <a:rPr lang="en-US" sz="1800" b="1" dirty="0">
+                <a:solidFill>
+                  <a:srgbClr val="1F2937"/>
+                </a:solidFill>
+                <a:latin typeface="Calibri" pitchFamily="34" charset="0"/>
+                <a:ea typeface="Calibri" pitchFamily="34" charset="-122"/>
+                <a:cs typeface="Calibri" pitchFamily="34" charset="-120"/>
+              </a:rPr>
+              <a:t>Show screenshots of legacy tools or manual processes</a:t>
+            </a:r>
+            <a:endParaRPr lang="en-US" sz="1800" dirty="0"/>
           </a:p>
           <a:p>
             <a:pPr marL="342900" indent="-342900">
@@ -2977,17 +3663,20 @@
               <a:buChar char="•"/>
             </a:pPr>
             <a:r>
-              <a:rPr lang="en-US" sz="1600" dirty="0">
-                <a:solidFill>
-                  <a:srgbClr val="374151"/>
-                </a:solidFill>
-              </a:rPr>
-              <a:t>Hiring plan</a:t>
-            </a:r>
-            <a:endParaRPr lang="en-US" sz="1600" dirty="0"/>
-          </a:p>
-          <a:p>
-            <a:pPr marL="342900" indent="-342900">
+              <a:rPr lang="en-US" sz="1800" b="1" dirty="0">
+                <a:solidFill>
+                  <a:srgbClr val="1F2937"/>
+                </a:solidFill>
+                <a:latin typeface="Calibri" pitchFamily="34" charset="0"/>
+                <a:ea typeface="Calibri" pitchFamily="34" charset="-122"/>
+                <a:cs typeface="Calibri" pitchFamily="34" charset="-120"/>
+              </a:rPr>
+              <a:t>Quantify the frustration</a:t>
+            </a:r>
+            <a:endParaRPr lang="en-US" sz="1800" dirty="0"/>
+          </a:p>
+          <a:p>
+            <a:pPr lvl="1" marL="685800" indent="-342900">
               <a:lnSpc>
                 <a:spcPts val="2800"/>
               </a:lnSpc>
@@ -2995,14 +3684,115 @@
               <a:buChar char="•"/>
             </a:pPr>
             <a:r>
-              <a:rPr lang="en-US" sz="1600" dirty="0">
-                <a:solidFill>
-                  <a:srgbClr val="374151"/>
-                </a:solidFill>
-              </a:rPr>
-              <a:t>Go-to-market acceleration</a:t>
-            </a:r>
-            <a:endParaRPr lang="en-US" sz="1600" dirty="0"/>
+              <a:rPr lang="en-US" sz="1800" dirty="0">
+                <a:solidFill>
+                  <a:srgbClr val="6B7280"/>
+                </a:solidFill>
+                <a:latin typeface="Calibri" pitchFamily="34" charset="0"/>
+                <a:ea typeface="Calibri" pitchFamily="34" charset="-122"/>
+                <a:cs typeface="Calibri" pitchFamily="34" charset="-120"/>
+              </a:rPr>
+              <a:t>Example: "$50K lost annually in productivity + $15K in late payment penalties"</a:t>
+            </a:r>
+            <a:endParaRPr lang="en-US" sz="1800" dirty="0"/>
+          </a:p>
+        </p:txBody>
+      </p:sp>
+      <p:sp>
+        <p:nvSpPr>
+          <p:cNvPr id="6" name="Shape 4"/>
+          <p:cNvSpPr/>
+          <p:nvPr/>
+        </p:nvSpPr>
+        <p:spPr>
+          <a:xfrm>
+            <a:off x="0" y="6720840"/>
+            <a:ext cx="73152" cy="137160"/>
+          </a:xfrm>
+          <a:prstGeom prst="rect">
+            <a:avLst/>
+          </a:prstGeom>
+          <a:solidFill>
+            <a:srgbClr val="38BDF8"/>
+          </a:solidFill>
+          <a:ln/>
+        </p:spPr>
+      </p:sp>
+      <p:sp>
+        <p:nvSpPr>
+          <p:cNvPr id="7" name="Text 5"/>
+          <p:cNvSpPr/>
+          <p:nvPr/>
+        </p:nvSpPr>
+        <p:spPr>
+          <a:xfrm>
+            <a:off x="274320" y="6720840"/>
+            <a:ext cx="2743200" cy="137160"/>
+          </a:xfrm>
+          <a:prstGeom prst="rect">
+            <a:avLst/>
+          </a:prstGeom>
+          <a:noFill/>
+          <a:ln/>
+        </p:spPr>
+        <p:txBody>
+          <a:bodyPr wrap="square" rtlCol="0" anchor="ctr"/>
+          <a:lstStyle/>
+          <a:p>
+            <a:pPr indent="0" marL="0">
+              <a:buNone/>
+            </a:pPr>
+            <a:r>
+              <a:rPr lang="en-US" sz="1000" dirty="0">
+                <a:solidFill>
+                  <a:srgbClr val="6B7280"/>
+                </a:solidFill>
+                <a:latin typeface="Calibri" pitchFamily="34" charset="0"/>
+                <a:ea typeface="Calibri" pitchFamily="34" charset="-122"/>
+                <a:cs typeface="Calibri" pitchFamily="34" charset="-120"/>
+              </a:rPr>
+              <a:t>Creatives Takeover</a:t>
+            </a:r>
+            <a:endParaRPr lang="en-US" sz="1000" dirty="0"/>
+          </a:p>
+        </p:txBody>
+      </p:sp>
+      <p:sp>
+        <p:nvSpPr>
+          <p:cNvPr id="8" name="Text 6"/>
+          <p:cNvSpPr/>
+          <p:nvPr/>
+        </p:nvSpPr>
+        <p:spPr>
+          <a:xfrm>
+            <a:off x="8412480" y="6720840"/>
+            <a:ext cx="274320" cy="137160"/>
+          </a:xfrm>
+          <a:prstGeom prst="rect">
+            <a:avLst/>
+          </a:prstGeom>
+          <a:noFill/>
+          <a:ln/>
+        </p:spPr>
+        <p:txBody>
+          <a:bodyPr wrap="square" rtlCol="0" anchor="ctr"/>
+          <a:lstStyle/>
+          <a:p>
+            <a:pPr algn="r" indent="0" marL="0">
+              <a:buNone/>
+            </a:pPr>
+            <a:r>
+              <a:rPr lang="en-US" sz="1000" dirty="0">
+                <a:solidFill>
+                  <a:srgbClr val="6B7280"/>
+                </a:solidFill>
+                <a:latin typeface="Calibri" pitchFamily="34" charset="0"/>
+                <a:ea typeface="Calibri" pitchFamily="34" charset="-122"/>
+                <a:cs typeface="Calibri" pitchFamily="34" charset="-120"/>
+              </a:rPr>
+              <a:t>2</a:t>
+            </a:r>
+            <a:endParaRPr lang="en-US" sz="1000" dirty="0"/>
           </a:p>
         </p:txBody>
       </p:sp>
@@ -3014,9 +3804,16 @@
 </p:sld>
 </file>
 
-<file path=ppt/slides/slide2.xml><?xml version="1.0" encoding="utf-8"?>
+<file path=ppt/slides/slide3.xml><?xml version="1.0" encoding="utf-8"?>
 <p:sld xmlns:a="http://schemas.openxmlformats.org/drawingml/2006/main" xmlns:r="http://schemas.openxmlformats.org/officeDocument/2006/relationships" xmlns:p="http://schemas.openxmlformats.org/presentationml/2006/main">
-  <p:cSld name="Slide 2">
+  <p:cSld name="Slide 3">
+    <p:bg>
+      <p:bgPr>
+        <a:solidFill>
+          <a:srgbClr val="FFFFFF"/>
+        </a:solidFill>
+      </p:bgPr>
+    </p:bg>
     <p:spTree>
       <p:nvGrpSpPr>
         <p:cNvPr id="1" name=""/>
@@ -3033,14 +3830,34 @@
       </p:grpSpPr>
       <p:sp>
         <p:nvSpPr>
-          <p:cNvPr id="2" name="Text 0"/>
-          <p:cNvSpPr/>
-          <p:nvPr/>
-        </p:nvSpPr>
-        <p:spPr>
-          <a:xfrm>
-            <a:off x="457200" y="457200"/>
-            <a:ext cx="8229600" cy="685800"/>
+          <p:cNvPr id="2" name="Shape 0"/>
+          <p:cNvSpPr/>
+          <p:nvPr/>
+        </p:nvSpPr>
+        <p:spPr>
+          <a:xfrm>
+            <a:off x="0" y="0"/>
+            <a:ext cx="9144000" cy="137160"/>
+          </a:xfrm>
+          <a:prstGeom prst="rect">
+            <a:avLst/>
+          </a:prstGeom>
+          <a:solidFill>
+            <a:srgbClr val="0B1437"/>
+          </a:solidFill>
+          <a:ln/>
+        </p:spPr>
+      </p:sp>
+      <p:sp>
+        <p:nvSpPr>
+          <p:cNvPr id="3" name="Text 1"/>
+          <p:cNvSpPr/>
+          <p:nvPr/>
+        </p:nvSpPr>
+        <p:spPr>
+          <a:xfrm>
+            <a:off x="457200" y="365760"/>
+            <a:ext cx="8229600" cy="548640"/>
           </a:xfrm>
           <a:prstGeom prst="rect">
             <a:avLst/>
@@ -3060,8 +3877,11 @@
                 <a:solidFill>
                   <a:srgbClr val="0B1437"/>
                 </a:solidFill>
-              </a:rPr>
-              <a:t>Cover Slide</a:t>
+                <a:latin typeface="Calibri" pitchFamily="34" charset="0"/>
+                <a:ea typeface="Calibri" pitchFamily="34" charset="-122"/>
+                <a:cs typeface="Calibri" pitchFamily="34" charset="-120"/>
+              </a:rPr>
+              <a:t>Meet the Product</a:t>
             </a:r>
             <a:endParaRPr lang="en-US" sz="3200" dirty="0"/>
           </a:p>
@@ -3069,7 +3889,46 @@
       </p:sp>
       <p:sp>
         <p:nvSpPr>
-          <p:cNvPr id="3" name="Text 1"/>
+          <p:cNvPr id="4" name="Text 2"/>
+          <p:cNvSpPr/>
+          <p:nvPr/>
+        </p:nvSpPr>
+        <p:spPr>
+          <a:xfrm>
+            <a:off x="457200" y="914400"/>
+            <a:ext cx="8229600" cy="365760"/>
+          </a:xfrm>
+          <a:prstGeom prst="rect">
+            <a:avLst/>
+          </a:prstGeom>
+          <a:noFill/>
+          <a:ln/>
+        </p:spPr>
+        <p:txBody>
+          <a:bodyPr wrap="square" rtlCol="0" anchor="ctr"/>
+          <a:lstStyle/>
+          <a:p>
+            <a:pPr indent="0" marL="0">
+              <a:buNone/>
+            </a:pPr>
+            <a:r>
+              <a:rPr lang="en-US" sz="1600" i="1" dirty="0">
+                <a:solidFill>
+                  <a:srgbClr val="6B7280"/>
+                </a:solidFill>
+                <a:latin typeface="Calibri" pitchFamily="34" charset="0"/>
+                <a:ea typeface="Calibri" pitchFamily="34" charset="-122"/>
+                <a:cs typeface="Calibri" pitchFamily="34" charset="-120"/>
+              </a:rPr>
+              <a:t>One-sentence value proposition</a:t>
+            </a:r>
+            <a:endParaRPr lang="en-US" sz="1600" dirty="0"/>
+          </a:p>
+        </p:txBody>
+      </p:sp>
+      <p:sp>
+        <p:nvSpPr>
+          <p:cNvPr id="5" name="Text 3"/>
           <p:cNvSpPr/>
           <p:nvPr/>
         </p:nvSpPr>
@@ -3096,14 +3955,17 @@
               <a:buChar char="•"/>
             </a:pPr>
             <a:r>
-              <a:rPr lang="en-US" sz="1600" dirty="0">
-                <a:solidFill>
-                  <a:srgbClr val="374151"/>
-                </a:solidFill>
-              </a:rPr>
-              <a:t>Company and product name</a:t>
-            </a:r>
-            <a:endParaRPr lang="en-US" sz="1600" dirty="0"/>
+              <a:rPr lang="en-US" sz="2400" b="1" dirty="0">
+                <a:solidFill>
+                  <a:srgbClr val="0B1437"/>
+                </a:solidFill>
+                <a:latin typeface="Calibri" pitchFamily="34" charset="0"/>
+                <a:ea typeface="Calibri" pitchFamily="34" charset="-122"/>
+                <a:cs typeface="Calibri" pitchFamily="34" charset="-120"/>
+              </a:rPr>
+              <a:t>[Product Name]: AI-powered invoicing that saves 18 hours/week</a:t>
+            </a:r>
+            <a:endParaRPr lang="en-US" sz="2400" dirty="0"/>
           </a:p>
           <a:p>
             <a:pPr marL="342900" indent="-342900">
@@ -3114,14 +3976,17 @@
               <a:buChar char="•"/>
             </a:pPr>
             <a:r>
-              <a:rPr lang="en-US" sz="1600" dirty="0">
-                <a:solidFill>
-                  <a:srgbClr val="374151"/>
-                </a:solidFill>
-              </a:rPr>
-              <a:t>One-line value prop</a:t>
-            </a:r>
-            <a:endParaRPr lang="en-US" sz="1600" dirty="0"/>
+              <a:rPr lang="en-US" sz="1800" b="1" dirty="0">
+                <a:solidFill>
+                  <a:srgbClr val="1F2937"/>
+                </a:solidFill>
+                <a:latin typeface="Calibri" pitchFamily="34" charset="0"/>
+                <a:ea typeface="Calibri" pitchFamily="34" charset="-122"/>
+                <a:cs typeface="Calibri" pitchFamily="34" charset="-120"/>
+              </a:rPr>
+              <a:t>Show product homepage or dashboard screenshot</a:t>
+            </a:r>
+            <a:endParaRPr lang="en-US" sz="2400" dirty="0"/>
           </a:p>
           <a:p>
             <a:pPr marL="342900" indent="-342900">
@@ -3132,14 +3997,178 @@
               <a:buChar char="•"/>
             </a:pPr>
             <a:r>
-              <a:rPr lang="en-US" sz="1600" dirty="0">
-                <a:solidFill>
-                  <a:srgbClr val="374151"/>
-                </a:solidFill>
-              </a:rPr>
-              <a:t>Product screenshot</a:t>
-            </a:r>
-            <a:endParaRPr lang="en-US" sz="1600" dirty="0"/>
+              <a:rPr lang="en-US" sz="1800" b="1" dirty="0">
+                <a:solidFill>
+                  <a:srgbClr val="1F2937"/>
+                </a:solidFill>
+                <a:latin typeface="Calibri" pitchFamily="34" charset="0"/>
+                <a:ea typeface="Calibri" pitchFamily="34" charset="-122"/>
+                <a:cs typeface="Calibri" pitchFamily="34" charset="-120"/>
+              </a:rPr>
+              <a:t>Highlight key stats visible in the UI:</a:t>
+            </a:r>
+            <a:endParaRPr lang="en-US" sz="2400" dirty="0"/>
+          </a:p>
+          <a:p>
+            <a:pPr lvl="1" marL="685800" indent="-342900">
+              <a:lnSpc>
+                <a:spcPts val="2800"/>
+              </a:lnSpc>
+              <a:buSzPct val="100000"/>
+              <a:buChar char="•"/>
+            </a:pPr>
+            <a:r>
+              <a:rPr lang="en-US" sz="1800" dirty="0">
+                <a:solidFill>
+                  <a:srgbClr val="10B981"/>
+                </a:solidFill>
+                <a:latin typeface="Calibri" pitchFamily="34" charset="0"/>
+                <a:ea typeface="Calibri" pitchFamily="34" charset="-122"/>
+                <a:cs typeface="Calibri" pitchFamily="34" charset="-120"/>
+              </a:rPr>
+              <a:t>Time saved this month: 72 hours</a:t>
+            </a:r>
+            <a:endParaRPr lang="en-US" sz="2400" dirty="0"/>
+          </a:p>
+          <a:p>
+            <a:pPr lvl="1" marL="685800" indent="-342900">
+              <a:lnSpc>
+                <a:spcPts val="2800"/>
+              </a:lnSpc>
+              <a:buSzPct val="100000"/>
+              <a:buChar char="•"/>
+            </a:pPr>
+            <a:r>
+              <a:rPr lang="en-US" sz="1800" dirty="0">
+                <a:solidFill>
+                  <a:srgbClr val="10B981"/>
+                </a:solidFill>
+                <a:latin typeface="Calibri" pitchFamily="34" charset="0"/>
+                <a:ea typeface="Calibri" pitchFamily="34" charset="-122"/>
+                <a:cs typeface="Calibri" pitchFamily="34" charset="-120"/>
+              </a:rPr>
+              <a:t>Invoices sent: 156 | Paid on time: 142 (91%)</a:t>
+            </a:r>
+            <a:endParaRPr lang="en-US" sz="2400" dirty="0"/>
+          </a:p>
+          <a:p>
+            <a:pPr lvl="1" marL="685800" indent="-342900">
+              <a:lnSpc>
+                <a:spcPts val="2800"/>
+              </a:lnSpc>
+              <a:buSzPct val="100000"/>
+              <a:buChar char="•"/>
+            </a:pPr>
+            <a:r>
+              <a:rPr lang="en-US" sz="1800" dirty="0">
+                <a:solidFill>
+                  <a:srgbClr val="10B981"/>
+                </a:solidFill>
+                <a:latin typeface="Calibri" pitchFamily="34" charset="0"/>
+                <a:ea typeface="Calibri" pitchFamily="34" charset="-122"/>
+                <a:cs typeface="Calibri" pitchFamily="34" charset="-120"/>
+              </a:rPr>
+              <a:t>Cash flow forecast: +$45K next 30 days</a:t>
+            </a:r>
+            <a:endParaRPr lang="en-US" sz="2400" dirty="0"/>
+          </a:p>
+        </p:txBody>
+      </p:sp>
+      <p:sp>
+        <p:nvSpPr>
+          <p:cNvPr id="6" name="Shape 4"/>
+          <p:cNvSpPr/>
+          <p:nvPr/>
+        </p:nvSpPr>
+        <p:spPr>
+          <a:xfrm>
+            <a:off x="0" y="6720840"/>
+            <a:ext cx="73152" cy="137160"/>
+          </a:xfrm>
+          <a:prstGeom prst="rect">
+            <a:avLst/>
+          </a:prstGeom>
+          <a:solidFill>
+            <a:srgbClr val="38BDF8"/>
+          </a:solidFill>
+          <a:ln/>
+        </p:spPr>
+      </p:sp>
+      <p:sp>
+        <p:nvSpPr>
+          <p:cNvPr id="7" name="Text 5"/>
+          <p:cNvSpPr/>
+          <p:nvPr/>
+        </p:nvSpPr>
+        <p:spPr>
+          <a:xfrm>
+            <a:off x="274320" y="6720840"/>
+            <a:ext cx="2743200" cy="137160"/>
+          </a:xfrm>
+          <a:prstGeom prst="rect">
+            <a:avLst/>
+          </a:prstGeom>
+          <a:noFill/>
+          <a:ln/>
+        </p:spPr>
+        <p:txBody>
+          <a:bodyPr wrap="square" rtlCol="0" anchor="ctr"/>
+          <a:lstStyle/>
+          <a:p>
+            <a:pPr indent="0" marL="0">
+              <a:buNone/>
+            </a:pPr>
+            <a:r>
+              <a:rPr lang="en-US" sz="1000" dirty="0">
+                <a:solidFill>
+                  <a:srgbClr val="6B7280"/>
+                </a:solidFill>
+                <a:latin typeface="Calibri" pitchFamily="34" charset="0"/>
+                <a:ea typeface="Calibri" pitchFamily="34" charset="-122"/>
+                <a:cs typeface="Calibri" pitchFamily="34" charset="-120"/>
+              </a:rPr>
+              <a:t>Creatives Takeover</a:t>
+            </a:r>
+            <a:endParaRPr lang="en-US" sz="1000" dirty="0"/>
+          </a:p>
+        </p:txBody>
+      </p:sp>
+      <p:sp>
+        <p:nvSpPr>
+          <p:cNvPr id="8" name="Text 6"/>
+          <p:cNvSpPr/>
+          <p:nvPr/>
+        </p:nvSpPr>
+        <p:spPr>
+          <a:xfrm>
+            <a:off x="8412480" y="6720840"/>
+            <a:ext cx="274320" cy="137160"/>
+          </a:xfrm>
+          <a:prstGeom prst="rect">
+            <a:avLst/>
+          </a:prstGeom>
+          <a:noFill/>
+          <a:ln/>
+        </p:spPr>
+        <p:txBody>
+          <a:bodyPr wrap="square" rtlCol="0" anchor="ctr"/>
+          <a:lstStyle/>
+          <a:p>
+            <a:pPr algn="r" indent="0" marL="0">
+              <a:buNone/>
+            </a:pPr>
+            <a:r>
+              <a:rPr lang="en-US" sz="1000" dirty="0">
+                <a:solidFill>
+                  <a:srgbClr val="6B7280"/>
+                </a:solidFill>
+                <a:latin typeface="Calibri" pitchFamily="34" charset="0"/>
+                <a:ea typeface="Calibri" pitchFamily="34" charset="-122"/>
+                <a:cs typeface="Calibri" pitchFamily="34" charset="-120"/>
+              </a:rPr>
+              <a:t>3</a:t>
+            </a:r>
+            <a:endParaRPr lang="en-US" sz="1000" dirty="0"/>
           </a:p>
         </p:txBody>
       </p:sp>
@@ -3151,9 +4180,16 @@
 </p:sld>
 </file>
 
-<file path=ppt/slides/slide3.xml><?xml version="1.0" encoding="utf-8"?>
+<file path=ppt/slides/slide4.xml><?xml version="1.0" encoding="utf-8"?>
 <p:sld xmlns:a="http://schemas.openxmlformats.org/drawingml/2006/main" xmlns:r="http://schemas.openxmlformats.org/officeDocument/2006/relationships" xmlns:p="http://schemas.openxmlformats.org/presentationml/2006/main">
-  <p:cSld name="Slide 3">
+  <p:cSld name="Slide 4">
+    <p:bg>
+      <p:bgPr>
+        <a:solidFill>
+          <a:srgbClr val="FFFFFF"/>
+        </a:solidFill>
+      </p:bgPr>
+    </p:bg>
     <p:spTree>
       <p:nvGrpSpPr>
         <p:cNvPr id="1" name=""/>
@@ -3170,14 +4206,34 @@
       </p:grpSpPr>
       <p:sp>
         <p:nvSpPr>
-          <p:cNvPr id="2" name="Text 0"/>
-          <p:cNvSpPr/>
-          <p:nvPr/>
-        </p:nvSpPr>
-        <p:spPr>
-          <a:xfrm>
-            <a:off x="457200" y="457200"/>
-            <a:ext cx="8229600" cy="685800"/>
+          <p:cNvPr id="2" name="Shape 0"/>
+          <p:cNvSpPr/>
+          <p:nvPr/>
+        </p:nvSpPr>
+        <p:spPr>
+          <a:xfrm>
+            <a:off x="0" y="0"/>
+            <a:ext cx="9144000" cy="137160"/>
+          </a:xfrm>
+          <a:prstGeom prst="rect">
+            <a:avLst/>
+          </a:prstGeom>
+          <a:solidFill>
+            <a:srgbClr val="0B1437"/>
+          </a:solidFill>
+          <a:ln/>
+        </p:spPr>
+      </p:sp>
+      <p:sp>
+        <p:nvSpPr>
+          <p:cNvPr id="3" name="Text 1"/>
+          <p:cNvSpPr/>
+          <p:nvPr/>
+        </p:nvSpPr>
+        <p:spPr>
+          <a:xfrm>
+            <a:off x="457200" y="365760"/>
+            <a:ext cx="8229600" cy="548640"/>
           </a:xfrm>
           <a:prstGeom prst="rect">
             <a:avLst/>
@@ -3197,8 +4253,11 @@
                 <a:solidFill>
                   <a:srgbClr val="0B1437"/>
                 </a:solidFill>
-              </a:rPr>
-              <a:t>Problem</a:t>
+                <a:latin typeface="Calibri" pitchFamily="34" charset="0"/>
+                <a:ea typeface="Calibri" pitchFamily="34" charset="-122"/>
+                <a:cs typeface="Calibri" pitchFamily="34" charset="-120"/>
+              </a:rPr>
+              <a:t>Step 1: Onboarding</a:t>
             </a:r>
             <a:endParaRPr lang="en-US" sz="3200" dirty="0"/>
           </a:p>
@@ -3206,7 +4265,46 @@
       </p:sp>
       <p:sp>
         <p:nvSpPr>
-          <p:cNvPr id="3" name="Text 1"/>
+          <p:cNvPr id="4" name="Text 2"/>
+          <p:cNvSpPr/>
+          <p:nvPr/>
+        </p:nvSpPr>
+        <p:spPr>
+          <a:xfrm>
+            <a:off x="457200" y="914400"/>
+            <a:ext cx="8229600" cy="365760"/>
+          </a:xfrm>
+          <a:prstGeom prst="rect">
+            <a:avLst/>
+          </a:prstGeom>
+          <a:noFill/>
+          <a:ln/>
+        </p:spPr>
+        <p:txBody>
+          <a:bodyPr wrap="square" rtlCol="0" anchor="ctr"/>
+          <a:lstStyle/>
+          <a:p>
+            <a:pPr indent="0" marL="0">
+              <a:buNone/>
+            </a:pPr>
+            <a:r>
+              <a:rPr lang="en-US" sz="1600" i="1" dirty="0">
+                <a:solidFill>
+                  <a:srgbClr val="6B7280"/>
+                </a:solidFill>
+                <a:latin typeface="Calibri" pitchFamily="34" charset="0"/>
+                <a:ea typeface="Calibri" pitchFamily="34" charset="-122"/>
+                <a:cs typeface="Calibri" pitchFamily="34" charset="-120"/>
+              </a:rPr>
+              <a:t>Getting started in 5 minutes</a:t>
+            </a:r>
+            <a:endParaRPr lang="en-US" sz="1600" dirty="0"/>
+          </a:p>
+        </p:txBody>
+      </p:sp>
+      <p:sp>
+        <p:nvSpPr>
+          <p:cNvPr id="5" name="Text 3"/>
           <p:cNvSpPr/>
           <p:nvPr/>
         </p:nvSpPr>
@@ -3233,14 +4331,17 @@
               <a:buChar char="•"/>
             </a:pPr>
             <a:r>
-              <a:rPr lang="en-US" sz="1600" dirty="0">
-                <a:solidFill>
-                  <a:srgbClr val="374151"/>
-                </a:solidFill>
-              </a:rPr>
-              <a:t>Specific user problem</a:t>
-            </a:r>
-            <a:endParaRPr lang="en-US" sz="1600" dirty="0"/>
+              <a:rPr lang="en-US" sz="1800" b="1" dirty="0">
+                <a:solidFill>
+                  <a:srgbClr val="1F2937"/>
+                </a:solidFill>
+                <a:latin typeface="Calibri" pitchFamily="34" charset="0"/>
+                <a:ea typeface="Calibri" pitchFamily="34" charset="-122"/>
+                <a:cs typeface="Calibri" pitchFamily="34" charset="-120"/>
+              </a:rPr>
+              <a:t>Screenshot: Simple signup form</a:t>
+            </a:r>
+            <a:endParaRPr lang="en-US" sz="1800" dirty="0"/>
           </a:p>
           <a:p>
             <a:pPr marL="342900" indent="-342900">
@@ -3251,14 +4352,17 @@
               <a:buChar char="•"/>
             </a:pPr>
             <a:r>
-              <a:rPr lang="en-US" sz="1600" dirty="0">
-                <a:solidFill>
-                  <a:srgbClr val="374151"/>
-                </a:solidFill>
-              </a:rPr>
-              <a:t>Current workflow pain</a:t>
-            </a:r>
-            <a:endParaRPr lang="en-US" sz="1600" dirty="0"/>
+              <a:rPr lang="en-US" sz="1800" b="1" dirty="0">
+                <a:solidFill>
+                  <a:srgbClr val="1F2937"/>
+                </a:solidFill>
+                <a:latin typeface="Calibri" pitchFamily="34" charset="0"/>
+                <a:ea typeface="Calibri" pitchFamily="34" charset="-122"/>
+                <a:cs typeface="Calibri" pitchFamily="34" charset="-120"/>
+              </a:rPr>
+              <a:t>Connect your bank account or accounting software (Stripe, QuickBooks, etc.)</a:t>
+            </a:r>
+            <a:endParaRPr lang="en-US" sz="1800" dirty="0"/>
           </a:p>
           <a:p>
             <a:pPr marL="342900" indent="-342900">
@@ -3269,14 +4373,157 @@
               <a:buChar char="•"/>
             </a:pPr>
             <a:r>
-              <a:rPr lang="en-US" sz="1600" dirty="0">
-                <a:solidFill>
-                  <a:srgbClr val="374151"/>
-                </a:solidFill>
-              </a:rPr>
-              <a:t>Quantify the impact</a:t>
-            </a:r>
-            <a:endParaRPr lang="en-US" sz="1600" dirty="0"/>
+              <a:rPr lang="en-US" sz="1800" b="1" dirty="0">
+                <a:solidFill>
+                  <a:srgbClr val="1F2937"/>
+                </a:solidFill>
+                <a:latin typeface="Calibri" pitchFamily="34" charset="0"/>
+                <a:ea typeface="Calibri" pitchFamily="34" charset="-122"/>
+                <a:cs typeface="Calibri" pitchFamily="34" charset="-120"/>
+              </a:rPr>
+              <a:t>Import your customer list (CSV, CRM sync, or manual entry)</a:t>
+            </a:r>
+            <a:endParaRPr lang="en-US" sz="1800" dirty="0"/>
+          </a:p>
+          <a:p>
+            <a:pPr marL="342900" indent="-342900">
+              <a:lnSpc>
+                <a:spcPts val="2800"/>
+              </a:lnSpc>
+              <a:buSzPct val="100000"/>
+              <a:buChar char="•"/>
+            </a:pPr>
+            <a:r>
+              <a:rPr lang="en-US" sz="1800" b="1" dirty="0">
+                <a:solidFill>
+                  <a:srgbClr val="1F2937"/>
+                </a:solidFill>
+                <a:latin typeface="Calibri" pitchFamily="34" charset="0"/>
+                <a:ea typeface="Calibri" pitchFamily="34" charset="-122"/>
+                <a:cs typeface="Calibri" pitchFamily="34" charset="-120"/>
+              </a:rPr>
+              <a:t>Choose your invoice template from our gallery</a:t>
+            </a:r>
+            <a:endParaRPr lang="en-US" sz="1800" dirty="0"/>
+          </a:p>
+          <a:p>
+            <a:pPr marL="342900" indent="-342900">
+              <a:lnSpc>
+                <a:spcPts val="2800"/>
+              </a:lnSpc>
+              <a:buSzPct val="100000"/>
+              <a:buChar char="•"/>
+            </a:pPr>
+            <a:r>
+              <a:rPr lang="en-US" sz="1800" b="1" dirty="0">
+                <a:solidFill>
+                  <a:srgbClr val="1F2937"/>
+                </a:solidFill>
+                <a:latin typeface="Calibri" pitchFamily="34" charset="0"/>
+                <a:ea typeface="Calibri" pitchFamily="34" charset="-122"/>
+                <a:cs typeface="Calibri" pitchFamily="34" charset="-120"/>
+              </a:rPr>
+              <a:t>Done! You're ready to send your first invoice</a:t>
+            </a:r>
+            <a:endParaRPr lang="en-US" sz="1800" dirty="0"/>
+          </a:p>
+        </p:txBody>
+      </p:sp>
+      <p:sp>
+        <p:nvSpPr>
+          <p:cNvPr id="6" name="Shape 4"/>
+          <p:cNvSpPr/>
+          <p:nvPr/>
+        </p:nvSpPr>
+        <p:spPr>
+          <a:xfrm>
+            <a:off x="0" y="6720840"/>
+            <a:ext cx="73152" cy="137160"/>
+          </a:xfrm>
+          <a:prstGeom prst="rect">
+            <a:avLst/>
+          </a:prstGeom>
+          <a:solidFill>
+            <a:srgbClr val="38BDF8"/>
+          </a:solidFill>
+          <a:ln/>
+        </p:spPr>
+      </p:sp>
+      <p:sp>
+        <p:nvSpPr>
+          <p:cNvPr id="7" name="Text 5"/>
+          <p:cNvSpPr/>
+          <p:nvPr/>
+        </p:nvSpPr>
+        <p:spPr>
+          <a:xfrm>
+            <a:off x="274320" y="6720840"/>
+            <a:ext cx="2743200" cy="137160"/>
+          </a:xfrm>
+          <a:prstGeom prst="rect">
+            <a:avLst/>
+          </a:prstGeom>
+          <a:noFill/>
+          <a:ln/>
+        </p:spPr>
+        <p:txBody>
+          <a:bodyPr wrap="square" rtlCol="0" anchor="ctr"/>
+          <a:lstStyle/>
+          <a:p>
+            <a:pPr indent="0" marL="0">
+              <a:buNone/>
+            </a:pPr>
+            <a:r>
+              <a:rPr lang="en-US" sz="1000" dirty="0">
+                <a:solidFill>
+                  <a:srgbClr val="6B7280"/>
+                </a:solidFill>
+                <a:latin typeface="Calibri" pitchFamily="34" charset="0"/>
+                <a:ea typeface="Calibri" pitchFamily="34" charset="-122"/>
+                <a:cs typeface="Calibri" pitchFamily="34" charset="-120"/>
+              </a:rPr>
+              <a:t>Creatives Takeover</a:t>
+            </a:r>
+            <a:endParaRPr lang="en-US" sz="1000" dirty="0"/>
+          </a:p>
+        </p:txBody>
+      </p:sp>
+      <p:sp>
+        <p:nvSpPr>
+          <p:cNvPr id="8" name="Text 6"/>
+          <p:cNvSpPr/>
+          <p:nvPr/>
+        </p:nvSpPr>
+        <p:spPr>
+          <a:xfrm>
+            <a:off x="8412480" y="6720840"/>
+            <a:ext cx="274320" cy="137160"/>
+          </a:xfrm>
+          <a:prstGeom prst="rect">
+            <a:avLst/>
+          </a:prstGeom>
+          <a:noFill/>
+          <a:ln/>
+        </p:spPr>
+        <p:txBody>
+          <a:bodyPr wrap="square" rtlCol="0" anchor="ctr"/>
+          <a:lstStyle/>
+          <a:p>
+            <a:pPr algn="r" indent="0" marL="0">
+              <a:buNone/>
+            </a:pPr>
+            <a:r>
+              <a:rPr lang="en-US" sz="1000" dirty="0">
+                <a:solidFill>
+                  <a:srgbClr val="6B7280"/>
+                </a:solidFill>
+                <a:latin typeface="Calibri" pitchFamily="34" charset="0"/>
+                <a:ea typeface="Calibri" pitchFamily="34" charset="-122"/>
+                <a:cs typeface="Calibri" pitchFamily="34" charset="-120"/>
+              </a:rPr>
+              <a:t>4</a:t>
+            </a:r>
+            <a:endParaRPr lang="en-US" sz="1000" dirty="0"/>
           </a:p>
         </p:txBody>
       </p:sp>
@@ -3288,9 +4535,16 @@
 </p:sld>
 </file>
 
-<file path=ppt/slides/slide4.xml><?xml version="1.0" encoding="utf-8"?>
+<file path=ppt/slides/slide5.xml><?xml version="1.0" encoding="utf-8"?>
 <p:sld xmlns:a="http://schemas.openxmlformats.org/drawingml/2006/main" xmlns:r="http://schemas.openxmlformats.org/officeDocument/2006/relationships" xmlns:p="http://schemas.openxmlformats.org/presentationml/2006/main">
-  <p:cSld name="Slide 4">
+  <p:cSld name="Slide 5">
+    <p:bg>
+      <p:bgPr>
+        <a:solidFill>
+          <a:srgbClr val="FFFFFF"/>
+        </a:solidFill>
+      </p:bgPr>
+    </p:bg>
     <p:spTree>
       <p:nvGrpSpPr>
         <p:cNvPr id="1" name=""/>
@@ -3307,14 +4561,34 @@
       </p:grpSpPr>
       <p:sp>
         <p:nvSpPr>
-          <p:cNvPr id="2" name="Text 0"/>
-          <p:cNvSpPr/>
-          <p:nvPr/>
-        </p:nvSpPr>
-        <p:spPr>
-          <a:xfrm>
-            <a:off x="457200" y="457200"/>
-            <a:ext cx="8229600" cy="685800"/>
+          <p:cNvPr id="2" name="Shape 0"/>
+          <p:cNvSpPr/>
+          <p:nvPr/>
+        </p:nvSpPr>
+        <p:spPr>
+          <a:xfrm>
+            <a:off x="0" y="0"/>
+            <a:ext cx="9144000" cy="137160"/>
+          </a:xfrm>
+          <a:prstGeom prst="rect">
+            <a:avLst/>
+          </a:prstGeom>
+          <a:solidFill>
+            <a:srgbClr val="0B1437"/>
+          </a:solidFill>
+          <a:ln/>
+        </p:spPr>
+      </p:sp>
+      <p:sp>
+        <p:nvSpPr>
+          <p:cNvPr id="3" name="Text 1"/>
+          <p:cNvSpPr/>
+          <p:nvPr/>
+        </p:nvSpPr>
+        <p:spPr>
+          <a:xfrm>
+            <a:off x="457200" y="365760"/>
+            <a:ext cx="8229600" cy="548640"/>
           </a:xfrm>
           <a:prstGeom prst="rect">
             <a:avLst/>
@@ -3334,8 +4608,11 @@
                 <a:solidFill>
                   <a:srgbClr val="0B1437"/>
                 </a:solidFill>
-              </a:rPr>
-              <a:t>Solution Overview</a:t>
+                <a:latin typeface="Calibri" pitchFamily="34" charset="0"/>
+                <a:ea typeface="Calibri" pitchFamily="34" charset="-122"/>
+                <a:cs typeface="Calibri" pitchFamily="34" charset="-120"/>
+              </a:rPr>
+              <a:t>Step 2: Create Invoice</a:t>
             </a:r>
             <a:endParaRPr lang="en-US" sz="3200" dirty="0"/>
           </a:p>
@@ -3343,7 +4620,46 @@
       </p:sp>
       <p:sp>
         <p:nvSpPr>
-          <p:cNvPr id="3" name="Text 1"/>
+          <p:cNvPr id="4" name="Text 2"/>
+          <p:cNvSpPr/>
+          <p:nvPr/>
+        </p:nvSpPr>
+        <p:spPr>
+          <a:xfrm>
+            <a:off x="457200" y="914400"/>
+            <a:ext cx="8229600" cy="365760"/>
+          </a:xfrm>
+          <a:prstGeom prst="rect">
+            <a:avLst/>
+          </a:prstGeom>
+          <a:noFill/>
+          <a:ln/>
+        </p:spPr>
+        <p:txBody>
+          <a:bodyPr wrap="square" rtlCol="0" anchor="ctr"/>
+          <a:lstStyle/>
+          <a:p>
+            <a:pPr indent="0" marL="0">
+              <a:buNone/>
+            </a:pPr>
+            <a:r>
+              <a:rPr lang="en-US" sz="1600" i="1" dirty="0">
+                <a:solidFill>
+                  <a:srgbClr val="6B7280"/>
+                </a:solidFill>
+                <a:latin typeface="Calibri" pitchFamily="34" charset="0"/>
+                <a:ea typeface="Calibri" pitchFamily="34" charset="-122"/>
+                <a:cs typeface="Calibri" pitchFamily="34" charset="-120"/>
+              </a:rPr>
+              <a:t>One-click invoice generation</a:t>
+            </a:r>
+            <a:endParaRPr lang="en-US" sz="1600" dirty="0"/>
+          </a:p>
+        </p:txBody>
+      </p:sp>
+      <p:sp>
+        <p:nvSpPr>
+          <p:cNvPr id="5" name="Text 3"/>
           <p:cNvSpPr/>
           <p:nvPr/>
         </p:nvSpPr>
@@ -3370,14 +4686,17 @@
               <a:buChar char="•"/>
             </a:pPr>
             <a:r>
-              <a:rPr lang="en-US" sz="1600" dirty="0">
-                <a:solidFill>
-                  <a:srgbClr val="374151"/>
-                </a:solidFill>
-              </a:rPr>
-              <a:t>How your product solves it</a:t>
-            </a:r>
-            <a:endParaRPr lang="en-US" sz="1600" dirty="0"/>
+              <a:rPr lang="en-US" sz="1800" b="1" dirty="0">
+                <a:solidFill>
+                  <a:srgbClr val="1F2937"/>
+                </a:solidFill>
+                <a:latin typeface="Calibri" pitchFamily="34" charset="0"/>
+                <a:ea typeface="Calibri" pitchFamily="34" charset="-122"/>
+                <a:cs typeface="Calibri" pitchFamily="34" charset="-120"/>
+              </a:rPr>
+              <a:t>Screenshot: Invoice creation screen</a:t>
+            </a:r>
+            <a:endParaRPr lang="en-US" sz="1800" dirty="0"/>
           </a:p>
           <a:p>
             <a:pPr marL="342900" indent="-342900">
@@ -3388,14 +4707,17 @@
               <a:buChar char="•"/>
             </a:pPr>
             <a:r>
-              <a:rPr lang="en-US" sz="1600" dirty="0">
-                <a:solidFill>
-                  <a:srgbClr val="374151"/>
-                </a:solidFill>
-              </a:rPr>
-              <a:t>Core value proposition</a:t>
-            </a:r>
-            <a:endParaRPr lang="en-US" sz="1600" dirty="0"/>
+              <a:rPr lang="en-US" sz="1800" b="1" dirty="0">
+                <a:solidFill>
+                  <a:srgbClr val="1F2937"/>
+                </a:solidFill>
+                <a:latin typeface="Calibri" pitchFamily="34" charset="0"/>
+                <a:ea typeface="Calibri" pitchFamily="34" charset="-122"/>
+                <a:cs typeface="Calibri" pitchFamily="34" charset="-120"/>
+              </a:rPr>
+              <a:t>Select customer from dropdown (AI suggests based on past patterns)</a:t>
+            </a:r>
+            <a:endParaRPr lang="en-US" sz="1800" dirty="0"/>
           </a:p>
           <a:p>
             <a:pPr marL="342900" indent="-342900">
@@ -3406,14 +4728,157 @@
               <a:buChar char="•"/>
             </a:pPr>
             <a:r>
-              <a:rPr lang="en-US" sz="1600" dirty="0">
-                <a:solidFill>
-                  <a:srgbClr val="374151"/>
-                </a:solidFill>
-              </a:rPr>
-              <a:t>Why it's better</a:t>
-            </a:r>
-            <a:endParaRPr lang="en-US" sz="1600" dirty="0"/>
+              <a:rPr lang="en-US" sz="1800" b="1" dirty="0">
+                <a:solidFill>
+                  <a:srgbClr val="1F2937"/>
+                </a:solidFill>
+                <a:latin typeface="Calibri" pitchFamily="34" charset="0"/>
+                <a:ea typeface="Calibri" pitchFamily="34" charset="-122"/>
+                <a:cs typeface="Calibri" pitchFamily="34" charset="-120"/>
+              </a:rPr>
+              <a:t>Add line items - our AI auto-fills based on your service catalog</a:t>
+            </a:r>
+            <a:endParaRPr lang="en-US" sz="1800" dirty="0"/>
+          </a:p>
+          <a:p>
+            <a:pPr lvl="1" marL="685800" indent="-342900">
+              <a:lnSpc>
+                <a:spcPts val="2800"/>
+              </a:lnSpc>
+              <a:buSzPct val="100000"/>
+              <a:buChar char="•"/>
+            </a:pPr>
+            <a:r>
+              <a:rPr lang="en-US" sz="1800" dirty="0">
+                <a:solidFill>
+                  <a:srgbClr val="6B7280"/>
+                </a:solidFill>
+                <a:latin typeface="Calibri" pitchFamily="34" charset="0"/>
+                <a:ea typeface="Calibri" pitchFamily="34" charset="-122"/>
+                <a:cs typeface="Calibri" pitchFamily="34" charset="-120"/>
+              </a:rPr>
+              <a:t>Example: "Consulting services - 10 hours @ $150/hr" pre-filled</a:t>
+            </a:r>
+            <a:endParaRPr lang="en-US" sz="1800" dirty="0"/>
+          </a:p>
+          <a:p>
+            <a:pPr marL="342900" indent="-342900">
+              <a:lnSpc>
+                <a:spcPts val="2800"/>
+              </a:lnSpc>
+              <a:buSzPct val="100000"/>
+              <a:buChar char="•"/>
+            </a:pPr>
+            <a:r>
+              <a:rPr lang="en-US" sz="1800" b="1" dirty="0">
+                <a:solidFill>
+                  <a:srgbClr val="1F2937"/>
+                </a:solidFill>
+                <a:latin typeface="Calibri" pitchFamily="34" charset="0"/>
+                <a:ea typeface="Calibri" pitchFamily="34" charset="-122"/>
+                <a:cs typeface="Calibri" pitchFamily="34" charset="-120"/>
+              </a:rPr>
+              <a:t>Review and send - takes 30 seconds vs 15 minutes manually</a:t>
+            </a:r>
+            <a:endParaRPr lang="en-US" sz="1800" dirty="0"/>
+          </a:p>
+        </p:txBody>
+      </p:sp>
+      <p:sp>
+        <p:nvSpPr>
+          <p:cNvPr id="6" name="Shape 4"/>
+          <p:cNvSpPr/>
+          <p:nvPr/>
+        </p:nvSpPr>
+        <p:spPr>
+          <a:xfrm>
+            <a:off x="0" y="6720840"/>
+            <a:ext cx="73152" cy="137160"/>
+          </a:xfrm>
+          <a:prstGeom prst="rect">
+            <a:avLst/>
+          </a:prstGeom>
+          <a:solidFill>
+            <a:srgbClr val="38BDF8"/>
+          </a:solidFill>
+          <a:ln/>
+        </p:spPr>
+      </p:sp>
+      <p:sp>
+        <p:nvSpPr>
+          <p:cNvPr id="7" name="Text 5"/>
+          <p:cNvSpPr/>
+          <p:nvPr/>
+        </p:nvSpPr>
+        <p:spPr>
+          <a:xfrm>
+            <a:off x="274320" y="6720840"/>
+            <a:ext cx="2743200" cy="137160"/>
+          </a:xfrm>
+          <a:prstGeom prst="rect">
+            <a:avLst/>
+          </a:prstGeom>
+          <a:noFill/>
+          <a:ln/>
+        </p:spPr>
+        <p:txBody>
+          <a:bodyPr wrap="square" rtlCol="0" anchor="ctr"/>
+          <a:lstStyle/>
+          <a:p>
+            <a:pPr indent="0" marL="0">
+              <a:buNone/>
+            </a:pPr>
+            <a:r>
+              <a:rPr lang="en-US" sz="1000" dirty="0">
+                <a:solidFill>
+                  <a:srgbClr val="6B7280"/>
+                </a:solidFill>
+                <a:latin typeface="Calibri" pitchFamily="34" charset="0"/>
+                <a:ea typeface="Calibri" pitchFamily="34" charset="-122"/>
+                <a:cs typeface="Calibri" pitchFamily="34" charset="-120"/>
+              </a:rPr>
+              <a:t>Creatives Takeover</a:t>
+            </a:r>
+            <a:endParaRPr lang="en-US" sz="1000" dirty="0"/>
+          </a:p>
+        </p:txBody>
+      </p:sp>
+      <p:sp>
+        <p:nvSpPr>
+          <p:cNvPr id="8" name="Text 6"/>
+          <p:cNvSpPr/>
+          <p:nvPr/>
+        </p:nvSpPr>
+        <p:spPr>
+          <a:xfrm>
+            <a:off x="8412480" y="6720840"/>
+            <a:ext cx="274320" cy="137160"/>
+          </a:xfrm>
+          <a:prstGeom prst="rect">
+            <a:avLst/>
+          </a:prstGeom>
+          <a:noFill/>
+          <a:ln/>
+        </p:spPr>
+        <p:txBody>
+          <a:bodyPr wrap="square" rtlCol="0" anchor="ctr"/>
+          <a:lstStyle/>
+          <a:p>
+            <a:pPr algn="r" indent="0" marL="0">
+              <a:buNone/>
+            </a:pPr>
+            <a:r>
+              <a:rPr lang="en-US" sz="1000" dirty="0">
+                <a:solidFill>
+                  <a:srgbClr val="6B7280"/>
+                </a:solidFill>
+                <a:latin typeface="Calibri" pitchFamily="34" charset="0"/>
+                <a:ea typeface="Calibri" pitchFamily="34" charset="-122"/>
+                <a:cs typeface="Calibri" pitchFamily="34" charset="-120"/>
+              </a:rPr>
+              <a:t>5</a:t>
+            </a:r>
+            <a:endParaRPr lang="en-US" sz="1000" dirty="0"/>
           </a:p>
         </p:txBody>
       </p:sp>
@@ -3425,9 +4890,16 @@
 </p:sld>
 </file>
 
-<file path=ppt/slides/slide5.xml><?xml version="1.0" encoding="utf-8"?>
+<file path=ppt/slides/slide6.xml><?xml version="1.0" encoding="utf-8"?>
 <p:sld xmlns:a="http://schemas.openxmlformats.org/drawingml/2006/main" xmlns:r="http://schemas.openxmlformats.org/officeDocument/2006/relationships" xmlns:p="http://schemas.openxmlformats.org/presentationml/2006/main">
-  <p:cSld name="Slide 5">
+  <p:cSld name="Slide 6">
+    <p:bg>
+      <p:bgPr>
+        <a:solidFill>
+          <a:srgbClr val="FFFFFF"/>
+        </a:solidFill>
+      </p:bgPr>
+    </p:bg>
     <p:spTree>
       <p:nvGrpSpPr>
         <p:cNvPr id="1" name=""/>
@@ -3444,14 +4916,34 @@
       </p:grpSpPr>
       <p:sp>
         <p:nvSpPr>
-          <p:cNvPr id="2" name="Text 0"/>
-          <p:cNvSpPr/>
-          <p:nvPr/>
-        </p:nvSpPr>
-        <p:spPr>
-          <a:xfrm>
-            <a:off x="457200" y="457200"/>
-            <a:ext cx="8229600" cy="685800"/>
+          <p:cNvPr id="2" name="Shape 0"/>
+          <p:cNvSpPr/>
+          <p:nvPr/>
+        </p:nvSpPr>
+        <p:spPr>
+          <a:xfrm>
+            <a:off x="0" y="0"/>
+            <a:ext cx="9144000" cy="137160"/>
+          </a:xfrm>
+          <a:prstGeom prst="rect">
+            <a:avLst/>
+          </a:prstGeom>
+          <a:solidFill>
+            <a:srgbClr val="0B1437"/>
+          </a:solidFill>
+          <a:ln/>
+        </p:spPr>
+      </p:sp>
+      <p:sp>
+        <p:nvSpPr>
+          <p:cNvPr id="3" name="Text 1"/>
+          <p:cNvSpPr/>
+          <p:nvPr/>
+        </p:nvSpPr>
+        <p:spPr>
+          <a:xfrm>
+            <a:off x="457200" y="365760"/>
+            <a:ext cx="8229600" cy="548640"/>
           </a:xfrm>
           <a:prstGeom prst="rect">
             <a:avLst/>
@@ -3471,8 +4963,11 @@
                 <a:solidFill>
                   <a:srgbClr val="0B1437"/>
                 </a:solidFill>
-              </a:rPr>
-              <a:t>Product Demo - Main Interface</a:t>
+                <a:latin typeface="Calibri" pitchFamily="34" charset="0"/>
+                <a:ea typeface="Calibri" pitchFamily="34" charset="-122"/>
+                <a:cs typeface="Calibri" pitchFamily="34" charset="-120"/>
+              </a:rPr>
+              <a:t>Step 3: Smart Reminders</a:t>
             </a:r>
             <a:endParaRPr lang="en-US" sz="3200" dirty="0"/>
           </a:p>
@@ -3480,7 +4975,46 @@
       </p:sp>
       <p:sp>
         <p:nvSpPr>
-          <p:cNvPr id="3" name="Text 1"/>
+          <p:cNvPr id="4" name="Text 2"/>
+          <p:cNvSpPr/>
+          <p:nvPr/>
+        </p:nvSpPr>
+        <p:spPr>
+          <a:xfrm>
+            <a:off x="457200" y="914400"/>
+            <a:ext cx="8229600" cy="365760"/>
+          </a:xfrm>
+          <a:prstGeom prst="rect">
+            <a:avLst/>
+          </a:prstGeom>
+          <a:noFill/>
+          <a:ln/>
+        </p:spPr>
+        <p:txBody>
+          <a:bodyPr wrap="square" rtlCol="0" anchor="ctr"/>
+          <a:lstStyle/>
+          <a:p>
+            <a:pPr indent="0" marL="0">
+              <a:buNone/>
+            </a:pPr>
+            <a:r>
+              <a:rPr lang="en-US" sz="1600" i="1" dirty="0">
+                <a:solidFill>
+                  <a:srgbClr val="6B7280"/>
+                </a:solidFill>
+                <a:latin typeface="Calibri" pitchFamily="34" charset="0"/>
+                <a:ea typeface="Calibri" pitchFamily="34" charset="-122"/>
+                <a:cs typeface="Calibri" pitchFamily="34" charset="-120"/>
+              </a:rPr>
+              <a:t>Automated payment tracking</a:t>
+            </a:r>
+            <a:endParaRPr lang="en-US" sz="1600" dirty="0"/>
+          </a:p>
+        </p:txBody>
+      </p:sp>
+      <p:sp>
+        <p:nvSpPr>
+          <p:cNvPr id="5" name="Text 3"/>
           <p:cNvSpPr/>
           <p:nvPr/>
         </p:nvSpPr>
@@ -3507,14 +5041,17 @@
               <a:buChar char="•"/>
             </a:pPr>
             <a:r>
-              <a:rPr lang="en-US" sz="1600" dirty="0">
-                <a:solidFill>
-                  <a:srgbClr val="374151"/>
-                </a:solidFill>
-              </a:rPr>
-              <a:t>Main dashboard or interface</a:t>
-            </a:r>
-            <a:endParaRPr lang="en-US" sz="1600" dirty="0"/>
+              <a:rPr lang="en-US" sz="1800" b="1" dirty="0">
+                <a:solidFill>
+                  <a:srgbClr val="1F2937"/>
+                </a:solidFill>
+                <a:latin typeface="Calibri" pitchFamily="34" charset="0"/>
+                <a:ea typeface="Calibri" pitchFamily="34" charset="-122"/>
+                <a:cs typeface="Calibri" pitchFamily="34" charset="-120"/>
+              </a:rPr>
+              <a:t>Screenshot: Payment tracking dashboard</a:t>
+            </a:r>
+            <a:endParaRPr lang="en-US" sz="1800" dirty="0"/>
           </a:p>
           <a:p>
             <a:pPr marL="342900" indent="-342900">
@@ -3525,14 +5062,38 @@
               <a:buChar char="•"/>
             </a:pPr>
             <a:r>
-              <a:rPr lang="en-US" sz="1600" dirty="0">
-                <a:solidFill>
-                  <a:srgbClr val="374151"/>
-                </a:solidFill>
-              </a:rPr>
-              <a:t>Primary use case</a:t>
-            </a:r>
-            <a:endParaRPr lang="en-US" sz="1600" dirty="0"/>
+              <a:rPr lang="en-US" sz="1800" b="1" dirty="0">
+                <a:solidFill>
+                  <a:srgbClr val="1F2937"/>
+                </a:solidFill>
+                <a:latin typeface="Calibri" pitchFamily="34" charset="0"/>
+                <a:ea typeface="Calibri" pitchFamily="34" charset="-122"/>
+                <a:cs typeface="Calibri" pitchFamily="34" charset="-120"/>
+              </a:rPr>
+              <a:t>AI automatically sends friendly reminders before due date</a:t>
+            </a:r>
+            <a:endParaRPr lang="en-US" sz="1800" dirty="0"/>
+          </a:p>
+          <a:p>
+            <a:pPr lvl="1" marL="685800" indent="-342900">
+              <a:lnSpc>
+                <a:spcPts val="2800"/>
+              </a:lnSpc>
+              <a:buSzPct val="100000"/>
+              <a:buChar char="•"/>
+            </a:pPr>
+            <a:r>
+              <a:rPr lang="en-US" sz="1800" dirty="0">
+                <a:solidFill>
+                  <a:srgbClr val="6B7280"/>
+                </a:solidFill>
+                <a:latin typeface="Calibri" pitchFamily="34" charset="0"/>
+                <a:ea typeface="Calibri" pitchFamily="34" charset="-122"/>
+                <a:cs typeface="Calibri" pitchFamily="34" charset="-120"/>
+              </a:rPr>
+              <a:t>Example: "Reminder sent 3 days before due date with personalized message"</a:t>
+            </a:r>
+            <a:endParaRPr lang="en-US" sz="1800" dirty="0"/>
           </a:p>
           <a:p>
             <a:pPr marL="342900" indent="-342900">
@@ -3543,17 +5104,20 @@
               <a:buChar char="•"/>
             </a:pPr>
             <a:r>
-              <a:rPr lang="en-US" sz="1600" dirty="0">
-                <a:solidFill>
-                  <a:srgbClr val="374151"/>
-                </a:solidFill>
-              </a:rPr>
-              <a:t>Clear annotations</a:t>
-            </a:r>
-            <a:endParaRPr lang="en-US" sz="1600" dirty="0"/>
-          </a:p>
-          <a:p>
-            <a:pPr marL="342900" indent="-342900">
+              <a:rPr lang="en-US" sz="1800" b="1" dirty="0">
+                <a:solidFill>
+                  <a:srgbClr val="1F2937"/>
+                </a:solidFill>
+                <a:latin typeface="Calibri" pitchFamily="34" charset="0"/>
+                <a:ea typeface="Calibri" pitchFamily="34" charset="-122"/>
+                <a:cs typeface="Calibri" pitchFamily="34" charset="-120"/>
+              </a:rPr>
+              <a:t>Escalation sequence for overdue invoices</a:t>
+            </a:r>
+            <a:endParaRPr lang="en-US" sz="1800" dirty="0"/>
+          </a:p>
+          <a:p>
+            <a:pPr lvl="1" marL="685800" indent="-342900">
               <a:lnSpc>
                 <a:spcPts val="2800"/>
               </a:lnSpc>
@@ -3561,14 +5125,157 @@
               <a:buChar char="•"/>
             </a:pPr>
             <a:r>
-              <a:rPr lang="en-US" sz="1600" dirty="0">
-                <a:solidFill>
-                  <a:srgbClr val="374151"/>
-                </a:solidFill>
-              </a:rPr>
-              <a:t>Focus on user benefit</a:t>
-            </a:r>
-            <a:endParaRPr lang="en-US" sz="1600" dirty="0"/>
+              <a:rPr lang="en-US" sz="1800" dirty="0">
+                <a:solidFill>
+                  <a:srgbClr val="6B7280"/>
+                </a:solidFill>
+                <a:latin typeface="Calibri" pitchFamily="34" charset="0"/>
+                <a:ea typeface="Calibri" pitchFamily="34" charset="-122"/>
+                <a:cs typeface="Calibri" pitchFamily="34" charset="-120"/>
+              </a:rPr>
+              <a:t>Day 1 overdue: Gentle reminder</a:t>
+            </a:r>
+            <a:endParaRPr lang="en-US" sz="1800" dirty="0"/>
+          </a:p>
+          <a:p>
+            <a:pPr lvl="1" marL="685800" indent="-342900">
+              <a:lnSpc>
+                <a:spcPts val="2800"/>
+              </a:lnSpc>
+              <a:buSzPct val="100000"/>
+              <a:buChar char="•"/>
+            </a:pPr>
+            <a:r>
+              <a:rPr lang="en-US" sz="1800" dirty="0">
+                <a:solidFill>
+                  <a:srgbClr val="6B7280"/>
+                </a:solidFill>
+                <a:latin typeface="Calibri" pitchFamily="34" charset="0"/>
+                <a:ea typeface="Calibri" pitchFamily="34" charset="-122"/>
+                <a:cs typeface="Calibri" pitchFamily="34" charset="-120"/>
+              </a:rPr>
+              <a:t>Day 7 overdue: Second notice with late fee warning</a:t>
+            </a:r>
+            <a:endParaRPr lang="en-US" sz="1800" dirty="0"/>
+          </a:p>
+          <a:p>
+            <a:pPr lvl="1" marL="685800" indent="-342900">
+              <a:lnSpc>
+                <a:spcPts val="2800"/>
+              </a:lnSpc>
+              <a:buSzPct val="100000"/>
+              <a:buChar char="•"/>
+            </a:pPr>
+            <a:r>
+              <a:rPr lang="en-US" sz="1800" dirty="0">
+                <a:solidFill>
+                  <a:srgbClr val="6B7280"/>
+                </a:solidFill>
+                <a:latin typeface="Calibri" pitchFamily="34" charset="0"/>
+                <a:ea typeface="Calibri" pitchFamily="34" charset="-122"/>
+                <a:cs typeface="Calibri" pitchFamily="34" charset="-120"/>
+              </a:rPr>
+              <a:t>Day 14 overdue: Final notice before collections</a:t>
+            </a:r>
+            <a:endParaRPr lang="en-US" sz="1800" dirty="0"/>
+          </a:p>
+        </p:txBody>
+      </p:sp>
+      <p:sp>
+        <p:nvSpPr>
+          <p:cNvPr id="6" name="Shape 4"/>
+          <p:cNvSpPr/>
+          <p:nvPr/>
+        </p:nvSpPr>
+        <p:spPr>
+          <a:xfrm>
+            <a:off x="0" y="6720840"/>
+            <a:ext cx="73152" cy="137160"/>
+          </a:xfrm>
+          <a:prstGeom prst="rect">
+            <a:avLst/>
+          </a:prstGeom>
+          <a:solidFill>
+            <a:srgbClr val="38BDF8"/>
+          </a:solidFill>
+          <a:ln/>
+        </p:spPr>
+      </p:sp>
+      <p:sp>
+        <p:nvSpPr>
+          <p:cNvPr id="7" name="Text 5"/>
+          <p:cNvSpPr/>
+          <p:nvPr/>
+        </p:nvSpPr>
+        <p:spPr>
+          <a:xfrm>
+            <a:off x="274320" y="6720840"/>
+            <a:ext cx="2743200" cy="137160"/>
+          </a:xfrm>
+          <a:prstGeom prst="rect">
+            <a:avLst/>
+          </a:prstGeom>
+          <a:noFill/>
+          <a:ln/>
+        </p:spPr>
+        <p:txBody>
+          <a:bodyPr wrap="square" rtlCol="0" anchor="ctr"/>
+          <a:lstStyle/>
+          <a:p>
+            <a:pPr indent="0" marL="0">
+              <a:buNone/>
+            </a:pPr>
+            <a:r>
+              <a:rPr lang="en-US" sz="1000" dirty="0">
+                <a:solidFill>
+                  <a:srgbClr val="6B7280"/>
+                </a:solidFill>
+                <a:latin typeface="Calibri" pitchFamily="34" charset="0"/>
+                <a:ea typeface="Calibri" pitchFamily="34" charset="-122"/>
+                <a:cs typeface="Calibri" pitchFamily="34" charset="-120"/>
+              </a:rPr>
+              <a:t>Creatives Takeover</a:t>
+            </a:r>
+            <a:endParaRPr lang="en-US" sz="1000" dirty="0"/>
+          </a:p>
+        </p:txBody>
+      </p:sp>
+      <p:sp>
+        <p:nvSpPr>
+          <p:cNvPr id="8" name="Text 6"/>
+          <p:cNvSpPr/>
+          <p:nvPr/>
+        </p:nvSpPr>
+        <p:spPr>
+          <a:xfrm>
+            <a:off x="8412480" y="6720840"/>
+            <a:ext cx="274320" cy="137160"/>
+          </a:xfrm>
+          <a:prstGeom prst="rect">
+            <a:avLst/>
+          </a:prstGeom>
+          <a:noFill/>
+          <a:ln/>
+        </p:spPr>
+        <p:txBody>
+          <a:bodyPr wrap="square" rtlCol="0" anchor="ctr"/>
+          <a:lstStyle/>
+          <a:p>
+            <a:pPr algn="r" indent="0" marL="0">
+              <a:buNone/>
+            </a:pPr>
+            <a:r>
+              <a:rPr lang="en-US" sz="1000" dirty="0">
+                <a:solidFill>
+                  <a:srgbClr val="6B7280"/>
+                </a:solidFill>
+                <a:latin typeface="Calibri" pitchFamily="34" charset="0"/>
+                <a:ea typeface="Calibri" pitchFamily="34" charset="-122"/>
+                <a:cs typeface="Calibri" pitchFamily="34" charset="-120"/>
+              </a:rPr>
+              <a:t>6</a:t>
+            </a:r>
+            <a:endParaRPr lang="en-US" sz="1000" dirty="0"/>
           </a:p>
         </p:txBody>
       </p:sp>
@@ -3580,9 +5287,16 @@
 </p:sld>
 </file>
 
-<file path=ppt/slides/slide6.xml><?xml version="1.0" encoding="utf-8"?>
+<file path=ppt/slides/slide7.xml><?xml version="1.0" encoding="utf-8"?>
 <p:sld xmlns:a="http://schemas.openxmlformats.org/drawingml/2006/main" xmlns:r="http://schemas.openxmlformats.org/officeDocument/2006/relationships" xmlns:p="http://schemas.openxmlformats.org/presentationml/2006/main">
-  <p:cSld name="Slide 6">
+  <p:cSld name="Slide 7">
+    <p:bg>
+      <p:bgPr>
+        <a:solidFill>
+          <a:srgbClr val="FFFFFF"/>
+        </a:solidFill>
+      </p:bgPr>
+    </p:bg>
     <p:spTree>
       <p:nvGrpSpPr>
         <p:cNvPr id="1" name=""/>
@@ -3599,14 +5313,34 @@
       </p:grpSpPr>
       <p:sp>
         <p:nvSpPr>
-          <p:cNvPr id="2" name="Text 0"/>
-          <p:cNvSpPr/>
-          <p:nvPr/>
-        </p:nvSpPr>
-        <p:spPr>
-          <a:xfrm>
-            <a:off x="457200" y="457200"/>
-            <a:ext cx="8229600" cy="685800"/>
+          <p:cNvPr id="2" name="Shape 0"/>
+          <p:cNvSpPr/>
+          <p:nvPr/>
+        </p:nvSpPr>
+        <p:spPr>
+          <a:xfrm>
+            <a:off x="0" y="0"/>
+            <a:ext cx="9144000" cy="137160"/>
+          </a:xfrm>
+          <a:prstGeom prst="rect">
+            <a:avLst/>
+          </a:prstGeom>
+          <a:solidFill>
+            <a:srgbClr val="0B1437"/>
+          </a:solidFill>
+          <a:ln/>
+        </p:spPr>
+      </p:sp>
+      <p:sp>
+        <p:nvSpPr>
+          <p:cNvPr id="3" name="Text 1"/>
+          <p:cNvSpPr/>
+          <p:nvPr/>
+        </p:nvSpPr>
+        <p:spPr>
+          <a:xfrm>
+            <a:off x="457200" y="365760"/>
+            <a:ext cx="8229600" cy="548640"/>
           </a:xfrm>
           <a:prstGeom prst="rect">
             <a:avLst/>
@@ -3626,8 +5360,11 @@
                 <a:solidFill>
                   <a:srgbClr val="0B1437"/>
                 </a:solidFill>
-              </a:rPr>
-              <a:t>Product Demo - Key Feature</a:t>
+                <a:latin typeface="Calibri" pitchFamily="34" charset="0"/>
+                <a:ea typeface="Calibri" pitchFamily="34" charset="-122"/>
+                <a:cs typeface="Calibri" pitchFamily="34" charset="-120"/>
+              </a:rPr>
+              <a:t>Step 4: Get Paid</a:t>
             </a:r>
             <a:endParaRPr lang="en-US" sz="3200" dirty="0"/>
           </a:p>
@@ -3635,7 +5372,46 @@
       </p:sp>
       <p:sp>
         <p:nvSpPr>
-          <p:cNvPr id="3" name="Text 1"/>
+          <p:cNvPr id="4" name="Text 2"/>
+          <p:cNvSpPr/>
+          <p:nvPr/>
+        </p:nvSpPr>
+        <p:spPr>
+          <a:xfrm>
+            <a:off x="457200" y="914400"/>
+            <a:ext cx="8229600" cy="365760"/>
+          </a:xfrm>
+          <a:prstGeom prst="rect">
+            <a:avLst/>
+          </a:prstGeom>
+          <a:noFill/>
+          <a:ln/>
+        </p:spPr>
+        <p:txBody>
+          <a:bodyPr wrap="square" rtlCol="0" anchor="ctr"/>
+          <a:lstStyle/>
+          <a:p>
+            <a:pPr indent="0" marL="0">
+              <a:buNone/>
+            </a:pPr>
+            <a:r>
+              <a:rPr lang="en-US" sz="1600" i="1" dirty="0">
+                <a:solidFill>
+                  <a:srgbClr val="6B7280"/>
+                </a:solidFill>
+                <a:latin typeface="Calibri" pitchFamily="34" charset="0"/>
+                <a:ea typeface="Calibri" pitchFamily="34" charset="-122"/>
+                <a:cs typeface="Calibri" pitchFamily="34" charset="-120"/>
+              </a:rPr>
+              <a:t>Instant payment reconciliation</a:t>
+            </a:r>
+            <a:endParaRPr lang="en-US" sz="1600" dirty="0"/>
+          </a:p>
+        </p:txBody>
+      </p:sp>
+      <p:sp>
+        <p:nvSpPr>
+          <p:cNvPr id="5" name="Text 3"/>
           <p:cNvSpPr/>
           <p:nvPr/>
         </p:nvSpPr>
@@ -3662,14 +5438,17 @@
               <a:buChar char="•"/>
             </a:pPr>
             <a:r>
-              <a:rPr lang="en-US" sz="1600" dirty="0">
-                <a:solidFill>
-                  <a:srgbClr val="374151"/>
-                </a:solidFill>
-              </a:rPr>
-              <a:t>Key differentiating feature</a:t>
-            </a:r>
-            <a:endParaRPr lang="en-US" sz="1600" dirty="0"/>
+              <a:rPr lang="en-US" sz="1800" b="1" dirty="0">
+                <a:solidFill>
+                  <a:srgbClr val="1F2937"/>
+                </a:solidFill>
+                <a:latin typeface="Calibri" pitchFamily="34" charset="0"/>
+                <a:ea typeface="Calibri" pitchFamily="34" charset="-122"/>
+                <a:cs typeface="Calibri" pitchFamily="34" charset="-120"/>
+              </a:rPr>
+              <a:t>Screenshot: Payment received notification</a:t>
+            </a:r>
+            <a:endParaRPr lang="en-US" sz="1800" dirty="0"/>
           </a:p>
           <a:p>
             <a:pPr marL="342900" indent="-342900">
@@ -3680,14 +5459,17 @@
               <a:buChar char="•"/>
             </a:pPr>
             <a:r>
-              <a:rPr lang="en-US" sz="1600" dirty="0">
-                <a:solidFill>
-                  <a:srgbClr val="374151"/>
-                </a:solidFill>
-              </a:rPr>
-              <a:t>How it works</a:t>
-            </a:r>
-            <a:endParaRPr lang="en-US" sz="1600" dirty="0"/>
+              <a:rPr lang="en-US" sz="1800" b="1" dirty="0">
+                <a:solidFill>
+                  <a:srgbClr val="1F2937"/>
+                </a:solidFill>
+                <a:latin typeface="Calibri" pitchFamily="34" charset="0"/>
+                <a:ea typeface="Calibri" pitchFamily="34" charset="-122"/>
+                <a:cs typeface="Calibri" pitchFamily="34" charset="-120"/>
+              </a:rPr>
+              <a:t>Customers can pay via credit card, bank transfer, or digital wallet</a:t>
+            </a:r>
+            <a:endParaRPr lang="en-US" sz="1800" dirty="0"/>
           </a:p>
           <a:p>
             <a:pPr marL="342900" indent="-342900">
@@ -3698,14 +5480,157 @@
               <a:buChar char="•"/>
             </a:pPr>
             <a:r>
-              <a:rPr lang="en-US" sz="1600" dirty="0">
-                <a:solidFill>
-                  <a:srgbClr val="374151"/>
-                </a:solidFill>
-              </a:rPr>
-              <a:t>User workflow</a:t>
-            </a:r>
-            <a:endParaRPr lang="en-US" sz="1600" dirty="0"/>
+              <a:rPr lang="en-US" sz="1800" b="1" dirty="0">
+                <a:solidFill>
+                  <a:srgbClr val="1F2937"/>
+                </a:solidFill>
+                <a:latin typeface="Calibri" pitchFamily="34" charset="0"/>
+                <a:ea typeface="Calibri" pitchFamily="34" charset="-122"/>
+                <a:cs typeface="Calibri" pitchFamily="34" charset="-120"/>
+              </a:rPr>
+              <a:t>Payment auto-syncs with your accounting software</a:t>
+            </a:r>
+            <a:endParaRPr lang="en-US" sz="1800" dirty="0"/>
+          </a:p>
+          <a:p>
+            <a:pPr lvl="1" marL="685800" indent="-342900">
+              <a:lnSpc>
+                <a:spcPts val="2800"/>
+              </a:lnSpc>
+              <a:buSzPct val="100000"/>
+              <a:buChar char="•"/>
+            </a:pPr>
+            <a:r>
+              <a:rPr lang="en-US" sz="1800" dirty="0">
+                <a:solidFill>
+                  <a:srgbClr val="6B7280"/>
+                </a:solidFill>
+                <a:latin typeface="Calibri" pitchFamily="34" charset="0"/>
+                <a:ea typeface="Calibri" pitchFamily="34" charset="-122"/>
+                <a:cs typeface="Calibri" pitchFamily="34" charset="-120"/>
+              </a:rPr>
+              <a:t>Example: "Invoice #1234 marked as paid, QuickBooks updated automatically"</a:t>
+            </a:r>
+            <a:endParaRPr lang="en-US" sz="1800" dirty="0"/>
+          </a:p>
+          <a:p>
+            <a:pPr marL="342900" indent="-342900">
+              <a:lnSpc>
+                <a:spcPts val="2800"/>
+              </a:lnSpc>
+              <a:buSzPct val="100000"/>
+              <a:buChar char="•"/>
+            </a:pPr>
+            <a:r>
+              <a:rPr lang="en-US" sz="1800" b="1" dirty="0">
+                <a:solidFill>
+                  <a:srgbClr val="1F2937"/>
+                </a:solidFill>
+                <a:latin typeface="Calibri" pitchFamily="34" charset="0"/>
+                <a:ea typeface="Calibri" pitchFamily="34" charset="-122"/>
+                <a:cs typeface="Calibri" pitchFamily="34" charset="-120"/>
+              </a:rPr>
+              <a:t>Instant receipt sent to customer</a:t>
+            </a:r>
+            <a:endParaRPr lang="en-US" sz="1800" dirty="0"/>
+          </a:p>
+        </p:txBody>
+      </p:sp>
+      <p:sp>
+        <p:nvSpPr>
+          <p:cNvPr id="6" name="Shape 4"/>
+          <p:cNvSpPr/>
+          <p:nvPr/>
+        </p:nvSpPr>
+        <p:spPr>
+          <a:xfrm>
+            <a:off x="0" y="6720840"/>
+            <a:ext cx="73152" cy="137160"/>
+          </a:xfrm>
+          <a:prstGeom prst="rect">
+            <a:avLst/>
+          </a:prstGeom>
+          <a:solidFill>
+            <a:srgbClr val="38BDF8"/>
+          </a:solidFill>
+          <a:ln/>
+        </p:spPr>
+      </p:sp>
+      <p:sp>
+        <p:nvSpPr>
+          <p:cNvPr id="7" name="Text 5"/>
+          <p:cNvSpPr/>
+          <p:nvPr/>
+        </p:nvSpPr>
+        <p:spPr>
+          <a:xfrm>
+            <a:off x="274320" y="6720840"/>
+            <a:ext cx="2743200" cy="137160"/>
+          </a:xfrm>
+          <a:prstGeom prst="rect">
+            <a:avLst/>
+          </a:prstGeom>
+          <a:noFill/>
+          <a:ln/>
+        </p:spPr>
+        <p:txBody>
+          <a:bodyPr wrap="square" rtlCol="0" anchor="ctr"/>
+          <a:lstStyle/>
+          <a:p>
+            <a:pPr indent="0" marL="0">
+              <a:buNone/>
+            </a:pPr>
+            <a:r>
+              <a:rPr lang="en-US" sz="1000" dirty="0">
+                <a:solidFill>
+                  <a:srgbClr val="6B7280"/>
+                </a:solidFill>
+                <a:latin typeface="Calibri" pitchFamily="34" charset="0"/>
+                <a:ea typeface="Calibri" pitchFamily="34" charset="-122"/>
+                <a:cs typeface="Calibri" pitchFamily="34" charset="-120"/>
+              </a:rPr>
+              <a:t>Creatives Takeover</a:t>
+            </a:r>
+            <a:endParaRPr lang="en-US" sz="1000" dirty="0"/>
+          </a:p>
+        </p:txBody>
+      </p:sp>
+      <p:sp>
+        <p:nvSpPr>
+          <p:cNvPr id="8" name="Text 6"/>
+          <p:cNvSpPr/>
+          <p:nvPr/>
+        </p:nvSpPr>
+        <p:spPr>
+          <a:xfrm>
+            <a:off x="8412480" y="6720840"/>
+            <a:ext cx="274320" cy="137160"/>
+          </a:xfrm>
+          <a:prstGeom prst="rect">
+            <a:avLst/>
+          </a:prstGeom>
+          <a:noFill/>
+          <a:ln/>
+        </p:spPr>
+        <p:txBody>
+          <a:bodyPr wrap="square" rtlCol="0" anchor="ctr"/>
+          <a:lstStyle/>
+          <a:p>
+            <a:pPr algn="r" indent="0" marL="0">
+              <a:buNone/>
+            </a:pPr>
+            <a:r>
+              <a:rPr lang="en-US" sz="1000" dirty="0">
+                <a:solidFill>
+                  <a:srgbClr val="6B7280"/>
+                </a:solidFill>
+                <a:latin typeface="Calibri" pitchFamily="34" charset="0"/>
+                <a:ea typeface="Calibri" pitchFamily="34" charset="-122"/>
+                <a:cs typeface="Calibri" pitchFamily="34" charset="-120"/>
+              </a:rPr>
+              <a:t>7</a:t>
+            </a:r>
+            <a:endParaRPr lang="en-US" sz="1000" dirty="0"/>
           </a:p>
         </p:txBody>
       </p:sp>
@@ -3717,9 +5642,16 @@
 </p:sld>
 </file>
 
-<file path=ppt/slides/slide7.xml><?xml version="1.0" encoding="utf-8"?>
+<file path=ppt/slides/slide8.xml><?xml version="1.0" encoding="utf-8"?>
 <p:sld xmlns:a="http://schemas.openxmlformats.org/drawingml/2006/main" xmlns:r="http://schemas.openxmlformats.org/officeDocument/2006/relationships" xmlns:p="http://schemas.openxmlformats.org/presentationml/2006/main">
-  <p:cSld name="Slide 7">
+  <p:cSld name="Slide 8">
+    <p:bg>
+      <p:bgPr>
+        <a:solidFill>
+          <a:srgbClr val="FFFFFF"/>
+        </a:solidFill>
+      </p:bgPr>
+    </p:bg>
     <p:spTree>
       <p:nvGrpSpPr>
         <p:cNvPr id="1" name=""/>
@@ -3736,14 +5668,34 @@
       </p:grpSpPr>
       <p:sp>
         <p:nvSpPr>
-          <p:cNvPr id="2" name="Text 0"/>
-          <p:cNvSpPr/>
-          <p:nvPr/>
-        </p:nvSpPr>
-        <p:spPr>
-          <a:xfrm>
-            <a:off x="457200" y="457200"/>
-            <a:ext cx="8229600" cy="685800"/>
+          <p:cNvPr id="2" name="Shape 0"/>
+          <p:cNvSpPr/>
+          <p:nvPr/>
+        </p:nvSpPr>
+        <p:spPr>
+          <a:xfrm>
+            <a:off x="0" y="0"/>
+            <a:ext cx="9144000" cy="137160"/>
+          </a:xfrm>
+          <a:prstGeom prst="rect">
+            <a:avLst/>
+          </a:prstGeom>
+          <a:solidFill>
+            <a:srgbClr val="0B1437"/>
+          </a:solidFill>
+          <a:ln/>
+        </p:spPr>
+      </p:sp>
+      <p:sp>
+        <p:nvSpPr>
+          <p:cNvPr id="3" name="Text 1"/>
+          <p:cNvSpPr/>
+          <p:nvPr/>
+        </p:nvSpPr>
+        <p:spPr>
+          <a:xfrm>
+            <a:off x="457200" y="365760"/>
+            <a:ext cx="8229600" cy="548640"/>
           </a:xfrm>
           <a:prstGeom prst="rect">
             <a:avLst/>
@@ -3763,8 +5715,11 @@
                 <a:solidFill>
                   <a:srgbClr val="0B1437"/>
                 </a:solidFill>
-              </a:rPr>
-              <a:t>Product Demo - Advanced Features</a:t>
+                <a:latin typeface="Calibri" pitchFamily="34" charset="0"/>
+                <a:ea typeface="Calibri" pitchFamily="34" charset="-122"/>
+                <a:cs typeface="Calibri" pitchFamily="34" charset="-120"/>
+              </a:rPr>
+              <a:t>Key Feature: AI Insights</a:t>
             </a:r>
             <a:endParaRPr lang="en-US" sz="3200" dirty="0"/>
           </a:p>
@@ -3772,7 +5727,46 @@
       </p:sp>
       <p:sp>
         <p:nvSpPr>
-          <p:cNvPr id="3" name="Text 1"/>
+          <p:cNvPr id="4" name="Text 2"/>
+          <p:cNvSpPr/>
+          <p:nvPr/>
+        </p:nvSpPr>
+        <p:spPr>
+          <a:xfrm>
+            <a:off x="457200" y="914400"/>
+            <a:ext cx="8229600" cy="365760"/>
+          </a:xfrm>
+          <a:prstGeom prst="rect">
+            <a:avLst/>
+          </a:prstGeom>
+          <a:noFill/>
+          <a:ln/>
+        </p:spPr>
+        <p:txBody>
+          <a:bodyPr wrap="square" rtlCol="0" anchor="ctr"/>
+          <a:lstStyle/>
+          <a:p>
+            <a:pPr indent="0" marL="0">
+              <a:buNone/>
+            </a:pPr>
+            <a:r>
+              <a:rPr lang="en-US" sz="1600" i="1" dirty="0">
+                <a:solidFill>
+                  <a:srgbClr val="6B7280"/>
+                </a:solidFill>
+                <a:latin typeface="Calibri" pitchFamily="34" charset="0"/>
+                <a:ea typeface="Calibri" pitchFamily="34" charset="-122"/>
+                <a:cs typeface="Calibri" pitchFamily="34" charset="-120"/>
+              </a:rPr>
+              <a:t>Cash flow forecasting</a:t>
+            </a:r>
+            <a:endParaRPr lang="en-US" sz="1600" dirty="0"/>
+          </a:p>
+        </p:txBody>
+      </p:sp>
+      <p:sp>
+        <p:nvSpPr>
+          <p:cNvPr id="5" name="Text 3"/>
           <p:cNvSpPr/>
           <p:nvPr/>
         </p:nvSpPr>
@@ -3799,14 +5793,17 @@
               <a:buChar char="•"/>
             </a:pPr>
             <a:r>
-              <a:rPr lang="en-US" sz="1600" dirty="0">
-                <a:solidFill>
-                  <a:srgbClr val="374151"/>
-                </a:solidFill>
-              </a:rPr>
-              <a:t>Power user features</a:t>
-            </a:r>
-            <a:endParaRPr lang="en-US" sz="1600" dirty="0"/>
+              <a:rPr lang="en-US" sz="1800" b="1" dirty="0">
+                <a:solidFill>
+                  <a:srgbClr val="1F2937"/>
+                </a:solidFill>
+                <a:latin typeface="Calibri" pitchFamily="34" charset="0"/>
+                <a:ea typeface="Calibri" pitchFamily="34" charset="-122"/>
+                <a:cs typeface="Calibri" pitchFamily="34" charset="-120"/>
+              </a:rPr>
+              <a:t>Screenshot: Analytics dashboard</a:t>
+            </a:r>
+            <a:endParaRPr lang="en-US" sz="1800" dirty="0"/>
           </a:p>
           <a:p>
             <a:pPr marL="342900" indent="-342900">
@@ -3817,14 +5814,38 @@
               <a:buChar char="•"/>
             </a:pPr>
             <a:r>
-              <a:rPr lang="en-US" sz="1600" dirty="0">
-                <a:solidFill>
-                  <a:srgbClr val="374151"/>
-                </a:solidFill>
-              </a:rPr>
-              <a:t>Integration capabilities</a:t>
-            </a:r>
-            <a:endParaRPr lang="en-US" sz="1600" dirty="0"/>
+              <a:rPr lang="en-US" sz="1800" b="1" dirty="0">
+                <a:solidFill>
+                  <a:srgbClr val="1F2937"/>
+                </a:solidFill>
+                <a:latin typeface="Calibri" pitchFamily="34" charset="0"/>
+                <a:ea typeface="Calibri" pitchFamily="34" charset="-122"/>
+                <a:cs typeface="Calibri" pitchFamily="34" charset="-120"/>
+              </a:rPr>
+              <a:t>AI predicts when customers will pay based on historical patterns</a:t>
+            </a:r>
+            <a:endParaRPr lang="en-US" sz="1800" dirty="0"/>
+          </a:p>
+          <a:p>
+            <a:pPr lvl="1" marL="685800" indent="-342900">
+              <a:lnSpc>
+                <a:spcPts val="2800"/>
+              </a:lnSpc>
+              <a:buSzPct val="100000"/>
+              <a:buChar char="•"/>
+            </a:pPr>
+            <a:r>
+              <a:rPr lang="en-US" sz="1800" dirty="0">
+                <a:solidFill>
+                  <a:srgbClr val="6B7280"/>
+                </a:solidFill>
+                <a:latin typeface="Calibri" pitchFamily="34" charset="0"/>
+                <a:ea typeface="Calibri" pitchFamily="34" charset="-122"/>
+                <a:cs typeface="Calibri" pitchFamily="34" charset="-120"/>
+              </a:rPr>
+              <a:t>Example: "Customer A typically pays 5 days early - forecast adjusted"</a:t>
+            </a:r>
+            <a:endParaRPr lang="en-US" sz="1800" dirty="0"/>
           </a:p>
           <a:p>
             <a:pPr marL="342900" indent="-342900">
@@ -3835,14 +5856,157 @@
               <a:buChar char="•"/>
             </a:pPr>
             <a:r>
-              <a:rPr lang="en-US" sz="1600" dirty="0">
-                <a:solidFill>
-                  <a:srgbClr val="374151"/>
-                </a:solidFill>
-              </a:rPr>
-              <a:t>Customization options</a:t>
-            </a:r>
-            <a:endParaRPr lang="en-US" sz="1600" dirty="0"/>
+              <a:rPr lang="en-US" sz="1800" b="1" dirty="0">
+                <a:solidFill>
+                  <a:srgbClr val="1F2937"/>
+                </a:solidFill>
+                <a:latin typeface="Calibri" pitchFamily="34" charset="0"/>
+                <a:ea typeface="Calibri" pitchFamily="34" charset="-122"/>
+                <a:cs typeface="Calibri" pitchFamily="34" charset="-120"/>
+              </a:rPr>
+              <a:t>See projected cash flow for next 30/60/90 days</a:t>
+            </a:r>
+            <a:endParaRPr lang="en-US" sz="1800" dirty="0"/>
+          </a:p>
+          <a:p>
+            <a:pPr marL="342900" indent="-342900">
+              <a:lnSpc>
+                <a:spcPts val="2800"/>
+              </a:lnSpc>
+              <a:buSzPct val="100000"/>
+              <a:buChar char="•"/>
+            </a:pPr>
+            <a:r>
+              <a:rPr lang="en-US" sz="1800" b="1" dirty="0">
+                <a:solidFill>
+                  <a:srgbClr val="1F2937"/>
+                </a:solidFill>
+                <a:latin typeface="Calibri" pitchFamily="34" charset="0"/>
+                <a:ea typeface="Calibri" pitchFamily="34" charset="-122"/>
+                <a:cs typeface="Calibri" pitchFamily="34" charset="-120"/>
+              </a:rPr>
+              <a:t>Identify at-risk customers before they become overdue</a:t>
+            </a:r>
+            <a:endParaRPr lang="en-US" sz="1800" dirty="0"/>
+          </a:p>
+          <a:p>
+            <a:pPr lvl="1" marL="685800" indent="-342900">
+              <a:lnSpc>
+                <a:spcPts val="2800"/>
+              </a:lnSpc>
+              <a:buSzPct val="100000"/>
+              <a:buChar char="•"/>
+            </a:pPr>
+            <a:r>
+              <a:rPr lang="en-US" sz="1800" dirty="0">
+                <a:solidFill>
+                  <a:srgbClr val="6B7280"/>
+                </a:solidFill>
+                <a:latin typeface="Calibri" pitchFamily="34" charset="0"/>
+                <a:ea typeface="Calibri" pitchFamily="34" charset="-122"/>
+                <a:cs typeface="Calibri" pitchFamily="34" charset="-120"/>
+              </a:rPr>
+              <a:t>Example: "Customer B has slowed payments by 10 days - flag for follow-up"</a:t>
+            </a:r>
+            <a:endParaRPr lang="en-US" sz="1800" dirty="0"/>
+          </a:p>
+        </p:txBody>
+      </p:sp>
+      <p:sp>
+        <p:nvSpPr>
+          <p:cNvPr id="6" name="Shape 4"/>
+          <p:cNvSpPr/>
+          <p:nvPr/>
+        </p:nvSpPr>
+        <p:spPr>
+          <a:xfrm>
+            <a:off x="0" y="6720840"/>
+            <a:ext cx="73152" cy="137160"/>
+          </a:xfrm>
+          <a:prstGeom prst="rect">
+            <a:avLst/>
+          </a:prstGeom>
+          <a:solidFill>
+            <a:srgbClr val="38BDF8"/>
+          </a:solidFill>
+          <a:ln/>
+        </p:spPr>
+      </p:sp>
+      <p:sp>
+        <p:nvSpPr>
+          <p:cNvPr id="7" name="Text 5"/>
+          <p:cNvSpPr/>
+          <p:nvPr/>
+        </p:nvSpPr>
+        <p:spPr>
+          <a:xfrm>
+            <a:off x="274320" y="6720840"/>
+            <a:ext cx="2743200" cy="137160"/>
+          </a:xfrm>
+          <a:prstGeom prst="rect">
+            <a:avLst/>
+          </a:prstGeom>
+          <a:noFill/>
+          <a:ln/>
+        </p:spPr>
+        <p:txBody>
+          <a:bodyPr wrap="square" rtlCol="0" anchor="ctr"/>
+          <a:lstStyle/>
+          <a:p>
+            <a:pPr indent="0" marL="0">
+              <a:buNone/>
+            </a:pPr>
+            <a:r>
+              <a:rPr lang="en-US" sz="1000" dirty="0">
+                <a:solidFill>
+                  <a:srgbClr val="6B7280"/>
+                </a:solidFill>
+                <a:latin typeface="Calibri" pitchFamily="34" charset="0"/>
+                <a:ea typeface="Calibri" pitchFamily="34" charset="-122"/>
+                <a:cs typeface="Calibri" pitchFamily="34" charset="-120"/>
+              </a:rPr>
+              <a:t>Creatives Takeover</a:t>
+            </a:r>
+            <a:endParaRPr lang="en-US" sz="1000" dirty="0"/>
+          </a:p>
+        </p:txBody>
+      </p:sp>
+      <p:sp>
+        <p:nvSpPr>
+          <p:cNvPr id="8" name="Text 6"/>
+          <p:cNvSpPr/>
+          <p:nvPr/>
+        </p:nvSpPr>
+        <p:spPr>
+          <a:xfrm>
+            <a:off x="8412480" y="6720840"/>
+            <a:ext cx="274320" cy="137160"/>
+          </a:xfrm>
+          <a:prstGeom prst="rect">
+            <a:avLst/>
+          </a:prstGeom>
+          <a:noFill/>
+          <a:ln/>
+        </p:spPr>
+        <p:txBody>
+          <a:bodyPr wrap="square" rtlCol="0" anchor="ctr"/>
+          <a:lstStyle/>
+          <a:p>
+            <a:pPr algn="r" indent="0" marL="0">
+              <a:buNone/>
+            </a:pPr>
+            <a:r>
+              <a:rPr lang="en-US" sz="1000" dirty="0">
+                <a:solidFill>
+                  <a:srgbClr val="6B7280"/>
+                </a:solidFill>
+                <a:latin typeface="Calibri" pitchFamily="34" charset="0"/>
+                <a:ea typeface="Calibri" pitchFamily="34" charset="-122"/>
+                <a:cs typeface="Calibri" pitchFamily="34" charset="-120"/>
+              </a:rPr>
+              <a:t>8</a:t>
+            </a:r>
+            <a:endParaRPr lang="en-US" sz="1000" dirty="0"/>
           </a:p>
         </p:txBody>
       </p:sp>
@@ -3854,9 +6018,16 @@
 </p:sld>
 </file>
 
-<file path=ppt/slides/slide8.xml><?xml version="1.0" encoding="utf-8"?>
+<file path=ppt/slides/slide9.xml><?xml version="1.0" encoding="utf-8"?>
 <p:sld xmlns:a="http://schemas.openxmlformats.org/drawingml/2006/main" xmlns:r="http://schemas.openxmlformats.org/officeDocument/2006/relationships" xmlns:p="http://schemas.openxmlformats.org/presentationml/2006/main">
-  <p:cSld name="Slide 8">
+  <p:cSld name="Slide 9">
+    <p:bg>
+      <p:bgPr>
+        <a:solidFill>
+          <a:srgbClr val="FFFFFF"/>
+        </a:solidFill>
+      </p:bgPr>
+    </p:bg>
     <p:spTree>
       <p:nvGrpSpPr>
         <p:cNvPr id="1" name=""/>
@@ -3873,14 +6044,34 @@
       </p:grpSpPr>
       <p:sp>
         <p:nvSpPr>
-          <p:cNvPr id="2" name="Text 0"/>
-          <p:cNvSpPr/>
-          <p:nvPr/>
-        </p:nvSpPr>
-        <p:spPr>
-          <a:xfrm>
-            <a:off x="457200" y="457200"/>
-            <a:ext cx="8229600" cy="685800"/>
+          <p:cNvPr id="2" name="Shape 0"/>
+          <p:cNvSpPr/>
+          <p:nvPr/>
+        </p:nvSpPr>
+        <p:spPr>
+          <a:xfrm>
+            <a:off x="0" y="0"/>
+            <a:ext cx="9144000" cy="137160"/>
+          </a:xfrm>
+          <a:prstGeom prst="rect">
+            <a:avLst/>
+          </a:prstGeom>
+          <a:solidFill>
+            <a:srgbClr val="0B1437"/>
+          </a:solidFill>
+          <a:ln/>
+        </p:spPr>
+      </p:sp>
+      <p:sp>
+        <p:nvSpPr>
+          <p:cNvPr id="3" name="Text 1"/>
+          <p:cNvSpPr/>
+          <p:nvPr/>
+        </p:nvSpPr>
+        <p:spPr>
+          <a:xfrm>
+            <a:off x="457200" y="365760"/>
+            <a:ext cx="8229600" cy="548640"/>
           </a:xfrm>
           <a:prstGeom prst="rect">
             <a:avLst/>
@@ -3900,8 +6091,11 @@
                 <a:solidFill>
                   <a:srgbClr val="0B1437"/>
                 </a:solidFill>
-              </a:rPr>
-              <a:t>User Experience</a:t>
+                <a:latin typeface="Calibri" pitchFamily="34" charset="0"/>
+                <a:ea typeface="Calibri" pitchFamily="34" charset="-122"/>
+                <a:cs typeface="Calibri" pitchFamily="34" charset="-120"/>
+              </a:rPr>
+              <a:t>Key Feature: Integrations</a:t>
             </a:r>
             <a:endParaRPr lang="en-US" sz="3200" dirty="0"/>
           </a:p>
@@ -3909,7 +6103,46 @@
       </p:sp>
       <p:sp>
         <p:nvSpPr>
-          <p:cNvPr id="3" name="Text 1"/>
+          <p:cNvPr id="4" name="Text 2"/>
+          <p:cNvSpPr/>
+          <p:nvPr/>
+        </p:nvSpPr>
+        <p:spPr>
+          <a:xfrm>
+            <a:off x="457200" y="914400"/>
+            <a:ext cx="8229600" cy="365760"/>
+          </a:xfrm>
+          <a:prstGeom prst="rect">
+            <a:avLst/>
+          </a:prstGeom>
+          <a:noFill/>
+          <a:ln/>
+        </p:spPr>
+        <p:txBody>
+          <a:bodyPr wrap="square" rtlCol="0" anchor="ctr"/>
+          <a:lstStyle/>
+          <a:p>
+            <a:pPr indent="0" marL="0">
+              <a:buNone/>
+            </a:pPr>
+            <a:r>
+              <a:rPr lang="en-US" sz="1600" i="1" dirty="0">
+                <a:solidFill>
+                  <a:srgbClr val="6B7280"/>
+                </a:solidFill>
+                <a:latin typeface="Calibri" pitchFamily="34" charset="0"/>
+                <a:ea typeface="Calibri" pitchFamily="34" charset="-122"/>
+                <a:cs typeface="Calibri" pitchFamily="34" charset="-120"/>
+              </a:rPr>
+              <a:t>Works with your existing tools</a:t>
+            </a:r>
+            <a:endParaRPr lang="en-US" sz="1600" dirty="0"/>
+          </a:p>
+        </p:txBody>
+      </p:sp>
+      <p:sp>
+        <p:nvSpPr>
+          <p:cNvPr id="5" name="Text 3"/>
           <p:cNvSpPr/>
           <p:nvPr/>
         </p:nvSpPr>
@@ -3936,14 +6169,17 @@
               <a:buChar char="•"/>
             </a:pPr>
             <a:r>
-              <a:rPr lang="en-US" sz="1600" dirty="0">
-                <a:solidFill>
-                  <a:srgbClr val="374151"/>
-                </a:solidFill>
-              </a:rPr>
-              <a:t>Onboarding flow</a:t>
-            </a:r>
-            <a:endParaRPr lang="en-US" sz="1600" dirty="0"/>
+              <a:rPr lang="en-US" sz="1800" b="1" dirty="0">
+                <a:solidFill>
+                  <a:srgbClr val="1F2937"/>
+                </a:solidFill>
+                <a:latin typeface="Calibri" pitchFamily="34" charset="0"/>
+                <a:ea typeface="Calibri" pitchFamily="34" charset="-122"/>
+                <a:cs typeface="Calibri" pitchFamily="34" charset="-120"/>
+              </a:rPr>
+              <a:t>Screenshot: Integrations page</a:t>
+            </a:r>
+            <a:endParaRPr lang="en-US" sz="1800" dirty="0"/>
           </a:p>
           <a:p>
             <a:pPr marL="342900" indent="-342900">
@@ -3954,17 +6190,20 @@
               <a:buChar char="•"/>
             </a:pPr>
             <a:r>
-              <a:rPr lang="en-US" sz="1600" dirty="0">
-                <a:solidFill>
-                  <a:srgbClr val="374151"/>
-                </a:solidFill>
-              </a:rPr>
-              <a:t>Ease of use</a:t>
-            </a:r>
-            <a:endParaRPr lang="en-US" sz="1600" dirty="0"/>
-          </a:p>
-          <a:p>
-            <a:pPr marL="342900" indent="-342900">
+              <a:rPr lang="en-US" sz="1800" b="1" dirty="0">
+                <a:solidFill>
+                  <a:srgbClr val="1F2937"/>
+                </a:solidFill>
+                <a:latin typeface="Calibri" pitchFamily="34" charset="0"/>
+                <a:ea typeface="Calibri" pitchFamily="34" charset="-122"/>
+                <a:cs typeface="Calibri" pitchFamily="34" charset="-120"/>
+              </a:rPr>
+              <a:t>Seamlessly connects with:</a:t>
+            </a:r>
+            <a:endParaRPr lang="en-US" sz="1800" dirty="0"/>
+          </a:p>
+          <a:p>
+            <a:pPr lvl="1" marL="685800" indent="-342900">
               <a:lnSpc>
                 <a:spcPts val="2800"/>
               </a:lnSpc>
@@ -3972,17 +6211,20 @@
               <a:buChar char="•"/>
             </a:pPr>
             <a:r>
-              <a:rPr lang="en-US" sz="1600" dirty="0">
-                <a:solidFill>
-                  <a:srgbClr val="374151"/>
-                </a:solidFill>
-              </a:rPr>
-              <a:t>Time to value</a:t>
-            </a:r>
-            <a:endParaRPr lang="en-US" sz="1600" dirty="0"/>
-          </a:p>
-          <a:p>
-            <a:pPr marL="342900" indent="-342900">
+              <a:rPr lang="en-US" sz="1800" dirty="0">
+                <a:solidFill>
+                  <a:srgbClr val="6B7280"/>
+                </a:solidFill>
+                <a:latin typeface="Calibri" pitchFamily="34" charset="0"/>
+                <a:ea typeface="Calibri" pitchFamily="34" charset="-122"/>
+                <a:cs typeface="Calibri" pitchFamily="34" charset="-120"/>
+              </a:rPr>
+              <a:t>Accounting: QuickBooks, Xero, FreshBooks</a:t>
+            </a:r>
+            <a:endParaRPr lang="en-US" sz="1800" dirty="0"/>
+          </a:p>
+          <a:p>
+            <a:pPr lvl="1" marL="685800" indent="-342900">
               <a:lnSpc>
                 <a:spcPts val="2800"/>
               </a:lnSpc>
@@ -3990,100 +6232,20 @@
               <a:buChar char="•"/>
             </a:pPr>
             <a:r>
-              <a:rPr lang="en-US" sz="1600" dirty="0">
-                <a:solidFill>
-                  <a:srgbClr val="374151"/>
-                </a:solidFill>
-              </a:rPr>
-              <a:t>User testimonials</a:t>
-            </a:r>
-            <a:endParaRPr lang="en-US" sz="1600" dirty="0"/>
-          </a:p>
-        </p:txBody>
-      </p:sp>
-    </p:spTree>
-  </p:cSld>
-  <p:clrMapOvr>
-    <a:masterClrMapping/>
-  </p:clrMapOvr>
-</p:sld>
-</file>
-
-<file path=ppt/slides/slide9.xml><?xml version="1.0" encoding="utf-8"?>
-<p:sld xmlns:a="http://schemas.openxmlformats.org/drawingml/2006/main" xmlns:r="http://schemas.openxmlformats.org/officeDocument/2006/relationships" xmlns:p="http://schemas.openxmlformats.org/presentationml/2006/main">
-  <p:cSld name="Slide 9">
-    <p:spTree>
-      <p:nvGrpSpPr>
-        <p:cNvPr id="1" name=""/>
-        <p:cNvGrpSpPr/>
-        <p:nvPr/>
-      </p:nvGrpSpPr>
-      <p:grpSpPr>
-        <a:xfrm>
-          <a:off x="0" y="0"/>
-          <a:ext cx="0" cy="0"/>
-          <a:chOff x="0" y="0"/>
-          <a:chExt cx="0" cy="0"/>
-        </a:xfrm>
-      </p:grpSpPr>
-      <p:sp>
-        <p:nvSpPr>
-          <p:cNvPr id="2" name="Text 0"/>
-          <p:cNvSpPr/>
-          <p:nvPr/>
-        </p:nvSpPr>
-        <p:spPr>
-          <a:xfrm>
-            <a:off x="457200" y="457200"/>
-            <a:ext cx="8229600" cy="685800"/>
-          </a:xfrm>
-          <a:prstGeom prst="rect">
-            <a:avLst/>
-          </a:prstGeom>
-          <a:noFill/>
-          <a:ln/>
-        </p:spPr>
-        <p:txBody>
-          <a:bodyPr wrap="square" rtlCol="0" anchor="ctr"/>
-          <a:lstStyle/>
-          <a:p>
-            <a:pPr indent="0" marL="0">
-              <a:buNone/>
-            </a:pPr>
-            <a:r>
-              <a:rPr lang="en-US" sz="3200" b="1" dirty="0">
-                <a:solidFill>
-                  <a:srgbClr val="0B1437"/>
-                </a:solidFill>
-              </a:rPr>
-              <a:t>Technology</a:t>
-            </a:r>
-            <a:endParaRPr lang="en-US" sz="3200" dirty="0"/>
-          </a:p>
-        </p:txBody>
-      </p:sp>
-      <p:sp>
-        <p:nvSpPr>
-          <p:cNvPr id="3" name="Text 1"/>
-          <p:cNvSpPr/>
-          <p:nvPr/>
-        </p:nvSpPr>
-        <p:spPr>
-          <a:xfrm>
-            <a:off x="457200" y="1371600"/>
-            <a:ext cx="8229600" cy="4114800"/>
-          </a:xfrm>
-          <a:prstGeom prst="rect">
-            <a:avLst/>
-          </a:prstGeom>
-          <a:noFill/>
-          <a:ln/>
-        </p:spPr>
-        <p:txBody>
-          <a:bodyPr wrap="square" rtlCol="0" anchor="ctr"/>
-          <a:lstStyle/>
-          <a:p>
-            <a:pPr marL="342900" indent="-342900">
+              <a:rPr lang="en-US" sz="1800" dirty="0">
+                <a:solidFill>
+                  <a:srgbClr val="6B7280"/>
+                </a:solidFill>
+                <a:latin typeface="Calibri" pitchFamily="34" charset="0"/>
+                <a:ea typeface="Calibri" pitchFamily="34" charset="-122"/>
+                <a:cs typeface="Calibri" pitchFamily="34" charset="-120"/>
+              </a:rPr>
+              <a:t>Payments: Stripe, PayPal, Square</a:t>
+            </a:r>
+            <a:endParaRPr lang="en-US" sz="1800" dirty="0"/>
+          </a:p>
+          <a:p>
+            <a:pPr lvl="1" marL="685800" indent="-342900">
               <a:lnSpc>
                 <a:spcPts val="2800"/>
               </a:lnSpc>
@@ -4091,17 +6253,20 @@
               <a:buChar char="•"/>
             </a:pPr>
             <a:r>
-              <a:rPr lang="en-US" sz="1600" dirty="0">
-                <a:solidFill>
-                  <a:srgbClr val="374151"/>
-                </a:solidFill>
-              </a:rPr>
-              <a:t>Architecture overview</a:t>
-            </a:r>
-            <a:endParaRPr lang="en-US" sz="1600" dirty="0"/>
-          </a:p>
-          <a:p>
-            <a:pPr marL="342900" indent="-342900">
+              <a:rPr lang="en-US" sz="1800" dirty="0">
+                <a:solidFill>
+                  <a:srgbClr val="6B7280"/>
+                </a:solidFill>
+                <a:latin typeface="Calibri" pitchFamily="34" charset="0"/>
+                <a:ea typeface="Calibri" pitchFamily="34" charset="-122"/>
+                <a:cs typeface="Calibri" pitchFamily="34" charset="-120"/>
+              </a:rPr>
+              <a:t>CRM: Salesforce, HubSpot, Pipedrive</a:t>
+            </a:r>
+            <a:endParaRPr lang="en-US" sz="1800" dirty="0"/>
+          </a:p>
+          <a:p>
+            <a:pPr lvl="1" marL="685800" indent="-342900">
               <a:lnSpc>
                 <a:spcPts val="2800"/>
               </a:lnSpc>
@@ -4109,50 +6274,115 @@
               <a:buChar char="•"/>
             </a:pPr>
             <a:r>
-              <a:rPr lang="en-US" sz="1600" dirty="0">
-                <a:solidFill>
-                  <a:srgbClr val="374151"/>
-                </a:solidFill>
-              </a:rPr>
-              <a:t>Technical innovation</a:t>
-            </a:r>
-            <a:endParaRPr lang="en-US" sz="1600" dirty="0"/>
-          </a:p>
-          <a:p>
-            <a:pPr marL="342900" indent="-342900">
-              <a:lnSpc>
-                <a:spcPts val="2800"/>
-              </a:lnSpc>
-              <a:buSzPct val="100000"/>
-              <a:buChar char="•"/>
-            </a:pPr>
-            <a:r>
-              <a:rPr lang="en-US" sz="1600" dirty="0">
-                <a:solidFill>
-                  <a:srgbClr val="374151"/>
-                </a:solidFill>
-              </a:rPr>
-              <a:t>Scalability</a:t>
-            </a:r>
-            <a:endParaRPr lang="en-US" sz="1600" dirty="0"/>
-          </a:p>
-          <a:p>
-            <a:pPr marL="342900" indent="-342900">
-              <a:lnSpc>
-                <a:spcPts val="2800"/>
-              </a:lnSpc>
-              <a:buSzPct val="100000"/>
-              <a:buChar char="•"/>
-            </a:pPr>
-            <a:r>
-              <a:rPr lang="en-US" sz="1600" dirty="0">
-                <a:solidFill>
-                  <a:srgbClr val="374151"/>
-                </a:solidFill>
-              </a:rPr>
-              <a:t>Security/compliance</a:t>
-            </a:r>
-            <a:endParaRPr lang="en-US" sz="1600" dirty="0"/>
+              <a:rPr lang="en-US" sz="1800" dirty="0">
+                <a:solidFill>
+                  <a:srgbClr val="6B7280"/>
+                </a:solidFill>
+                <a:latin typeface="Calibri" pitchFamily="34" charset="0"/>
+                <a:ea typeface="Calibri" pitchFamily="34" charset="-122"/>
+                <a:cs typeface="Calibri" pitchFamily="34" charset="-120"/>
+              </a:rPr>
+              <a:t>Communication: Slack, Gmail, Microsoft Teams</a:t>
+            </a:r>
+            <a:endParaRPr lang="en-US" sz="1800" dirty="0"/>
+          </a:p>
+        </p:txBody>
+      </p:sp>
+      <p:sp>
+        <p:nvSpPr>
+          <p:cNvPr id="6" name="Shape 4"/>
+          <p:cNvSpPr/>
+          <p:nvPr/>
+        </p:nvSpPr>
+        <p:spPr>
+          <a:xfrm>
+            <a:off x="0" y="6720840"/>
+            <a:ext cx="73152" cy="137160"/>
+          </a:xfrm>
+          <a:prstGeom prst="rect">
+            <a:avLst/>
+          </a:prstGeom>
+          <a:solidFill>
+            <a:srgbClr val="38BDF8"/>
+          </a:solidFill>
+          <a:ln/>
+        </p:spPr>
+      </p:sp>
+      <p:sp>
+        <p:nvSpPr>
+          <p:cNvPr id="7" name="Text 5"/>
+          <p:cNvSpPr/>
+          <p:nvPr/>
+        </p:nvSpPr>
+        <p:spPr>
+          <a:xfrm>
+            <a:off x="274320" y="6720840"/>
+            <a:ext cx="2743200" cy="137160"/>
+          </a:xfrm>
+          <a:prstGeom prst="rect">
+            <a:avLst/>
+          </a:prstGeom>
+          <a:noFill/>
+          <a:ln/>
+        </p:spPr>
+        <p:txBody>
+          <a:bodyPr wrap="square" rtlCol="0" anchor="ctr"/>
+          <a:lstStyle/>
+          <a:p>
+            <a:pPr indent="0" marL="0">
+              <a:buNone/>
+            </a:pPr>
+            <a:r>
+              <a:rPr lang="en-US" sz="1000" dirty="0">
+                <a:solidFill>
+                  <a:srgbClr val="6B7280"/>
+                </a:solidFill>
+                <a:latin typeface="Calibri" pitchFamily="34" charset="0"/>
+                <a:ea typeface="Calibri" pitchFamily="34" charset="-122"/>
+                <a:cs typeface="Calibri" pitchFamily="34" charset="-120"/>
+              </a:rPr>
+              <a:t>Creatives Takeover</a:t>
+            </a:r>
+            <a:endParaRPr lang="en-US" sz="1000" dirty="0"/>
+          </a:p>
+        </p:txBody>
+      </p:sp>
+      <p:sp>
+        <p:nvSpPr>
+          <p:cNvPr id="8" name="Text 6"/>
+          <p:cNvSpPr/>
+          <p:nvPr/>
+        </p:nvSpPr>
+        <p:spPr>
+          <a:xfrm>
+            <a:off x="8412480" y="6720840"/>
+            <a:ext cx="274320" cy="137160"/>
+          </a:xfrm>
+          <a:prstGeom prst="rect">
+            <a:avLst/>
+          </a:prstGeom>
+          <a:noFill/>
+          <a:ln/>
+        </p:spPr>
+        <p:txBody>
+          <a:bodyPr wrap="square" rtlCol="0" anchor="ctr"/>
+          <a:lstStyle/>
+          <a:p>
+            <a:pPr algn="r" indent="0" marL="0">
+              <a:buNone/>
+            </a:pPr>
+            <a:r>
+              <a:rPr lang="en-US" sz="1000" dirty="0">
+                <a:solidFill>
+                  <a:srgbClr val="6B7280"/>
+                </a:solidFill>
+                <a:latin typeface="Calibri" pitchFamily="34" charset="0"/>
+                <a:ea typeface="Calibri" pitchFamily="34" charset="-122"/>
+                <a:cs typeface="Calibri" pitchFamily="34" charset="-120"/>
+              </a:rPr>
+              <a:t>9</a:t>
+            </a:r>
+            <a:endParaRPr lang="en-US" sz="1000" dirty="0"/>
           </a:p>
         </p:txBody>
       </p:sp>

</xml_diff>